<commit_message>
feat(slides): put real media in the decks — 81 rendered diagrams, no placeholders
The decks shipped as bullet lists with empty 'MEDIA PASS' boxes, which is not a deck
an SA can present. Every module's mermaid concept diagrams are now rendered and
embedded:
  • 33 slides whose outline names a diagram -> split layout, points beside the diagram
  • 49 diagrams no slide claimed          -> full-width concept slides per module
  • slides with no diagram                -> clean two-column point cards, no empty frame
All 81 diagrams are used; every one of the 26 module decks now carries real visuals.

Rendering pipeline used only what's installed (no new tooling): mermaid rendered in a
browser with htmlLabels off so labels emit as native SVG <text> (foreignObject renders
blank through rsvg), then rsvg-convert to 1600px PNG. Verified by rendering the decks
to montages and reading them.
</commit_message>
<xml_diff>
--- a/slides/modules/m01-platform-orientation.pptx
+++ b/slides/modules/m01-platform-orientation.pptx
@@ -12,6 +12,7 @@
     <p:sldId id="260" r:id="rId12"/>
     <p:sldId id="261" r:id="rId13"/>
     <p:sldId id="262" r:id="rId14"/>
+    <p:sldId id="263" r:id="rId15"/>
   </p:sldIdLst>
   <p:sldSz cx="12191695" cy="6858000" type="screen4x3"/>
   <p:notesSz cx="6858000" cy="9144000"/>
@@ -859,6 +860,76 @@
           <a:p>
             <a:r>
               <a:t>Land the transfer to their world and stay honest. Discussion prompts: what is self-service versus ticket-and-wait today; how long to recover a real service if its box vanished; where are your genuine pets. Then the credibility close — self-healing disposable workloads are the default, not always: stateful data, legacy appliances, and licensed VMs have their place, covered in later modules. Choosing is the skill.</a:t>
+            </a:r>
+          </a:p>
+        </p:txBody>
+      </p:sp>
+      <p:sp>
+        <p:nvSpPr>
+          <p:cNvPr id="4" name="Slide Number Placeholder 3"/>
+          <p:cNvSpPr>
+            <a:spLocks noGrp="1"/>
+          </p:cNvSpPr>
+          <p:nvPr>
+            <p:ph type="sldNum" idx="5" sz="quarter"/>
+          </p:nvPr>
+        </p:nvSpPr>
+        <p:spPr/>
+      </p:sp>
+    </p:spTree>
+  </p:cSld>
+  <p:clrMapOvr>
+    <a:masterClrMapping/>
+  </p:clrMapOvr>
+</p:notes>
+</file>
+
+<file path=ppt/notesSlides/notesSlide7.xml><?xml version="1.0" encoding="utf-8"?>
+<p:notes xmlns:a="http://schemas.openxmlformats.org/drawingml/2006/main" xmlns:p="http://schemas.openxmlformats.org/presentationml/2006/main" xmlns:r="http://schemas.openxmlformats.org/officeDocument/2006/relationships">
+  <p:cSld>
+    <p:spTree>
+      <p:nvGrpSpPr>
+        <p:cNvPr id="1" name=""/>
+        <p:cNvGrpSpPr/>
+        <p:nvPr/>
+      </p:nvGrpSpPr>
+      <p:grpSpPr>
+        <a:xfrm>
+          <a:off x="0" y="0"/>
+          <a:ext cx="0" cy="0"/>
+          <a:chOff x="0" y="0"/>
+          <a:chExt cx="0" cy="0"/>
+        </a:xfrm>
+      </p:grpSpPr>
+      <p:sp>
+        <p:nvSpPr>
+          <p:cNvPr id="2" name="Slide Image Placeholder 1"/>
+          <p:cNvSpPr>
+            <a:spLocks noGrp="1"/>
+          </p:cNvSpPr>
+          <p:nvPr>
+            <p:ph type="sldImg" idx="2"/>
+          </p:nvPr>
+        </p:nvSpPr>
+        <p:spPr/>
+      </p:sp>
+      <p:sp>
+        <p:nvSpPr>
+          <p:cNvPr id="3" name="Notes Placeholder 2"/>
+          <p:cNvSpPr>
+            <a:spLocks noGrp="1"/>
+          </p:cNvSpPr>
+          <p:nvPr>
+            <p:ph type="body" idx="3" sz="quarter"/>
+          </p:nvPr>
+        </p:nvSpPr>
+        <p:spPr/>
+        <p:txBody>
+          <a:bodyPr/>
+          <a:lstStyle/>
+          <a:p>
+            <a:r>
+              <a:t>Concept diagram: What you built.</a:t>
             </a:r>
           </a:p>
         </p:txBody>
@@ -4236,11 +4307,11 @@
         <p:spPr>
           <a:xfrm>
             <a:off x="841248" y="2395728"/>
-            <a:ext cx="5715000" cy="530352"/>
+            <a:ext cx="5138928" cy="786384"/>
           </a:xfrm>
           <a:prstGeom prst="roundRect">
             <a:avLst>
-              <a:gd name="adj" fmla="val 6000"/>
+              <a:gd name="adj" fmla="val 7000"/>
             </a:avLst>
           </a:prstGeom>
           <a:solidFill>
@@ -4275,9 +4346,55 @@
           </a:p>
         </p:txBody>
       </p:sp>
+      <p:sp>
+        <p:nvSpPr>
+          <p:cNvPr id="7" name="Rounded Rectangle 6"/>
+          <p:cNvSpPr/>
+          <p:nvPr/>
+        </p:nvSpPr>
+        <p:spPr>
+          <a:xfrm>
+            <a:off x="987552" y="2532888"/>
+            <a:ext cx="512064" cy="512064"/>
+          </a:xfrm>
+          <a:prstGeom prst="roundRect">
+            <a:avLst>
+              <a:gd name="adj" fmla="val 26000"/>
+            </a:avLst>
+          </a:prstGeom>
+          <a:solidFill>
+            <a:srgbClr val="EE0000"/>
+          </a:solidFill>
+          <a:ln>
+            <a:noFill/>
+          </a:ln>
+          <a:effectLst/>
+        </p:spPr>
+        <p:style>
+          <a:lnRef idx="1">
+            <a:schemeClr val="accent1"/>
+          </a:lnRef>
+          <a:fillRef idx="3">
+            <a:schemeClr val="accent1"/>
+          </a:fillRef>
+          <a:effectRef idx="2">
+            <a:schemeClr val="accent1"/>
+          </a:effectRef>
+          <a:fontRef idx="minor">
+            <a:schemeClr val="lt1"/>
+          </a:fontRef>
+        </p:style>
+        <p:txBody>
+          <a:bodyPr rtlCol="0" anchor="ctr"/>
+          <a:lstStyle/>
+          <a:p>
+            <a:pPr algn="ctr"/>
+          </a:p>
+        </p:txBody>
+      </p:sp>
       <p:pic>
         <p:nvPicPr>
-          <p:cNvPr id="7" name="Picture 6" descr="check_steel.png"/>
+          <p:cNvPr id="8" name="Picture 7" descr="check_white.png"/>
           <p:cNvPicPr>
             <a:picLocks noChangeAspect="1"/>
           </p:cNvPicPr>
@@ -4291,8 +4408,8 @@
         </p:blipFill>
         <p:spPr>
           <a:xfrm>
-            <a:off x="987552" y="2542032"/>
-            <a:ext cx="237744" cy="237744"/>
+            <a:off x="1110447" y="2655783"/>
+            <a:ext cx="266273" cy="266273"/>
           </a:xfrm>
           <a:prstGeom prst="rect">
             <a:avLst/>
@@ -4301,14 +4418,14 @@
       </p:pic>
       <p:sp>
         <p:nvSpPr>
-          <p:cNvPr id="8" name="TextBox 7"/>
+          <p:cNvPr id="9" name="TextBox 8"/>
           <p:cNvSpPr txBox="1"/>
           <p:nvPr/>
         </p:nvSpPr>
         <p:spPr>
           <a:xfrm>
-            <a:off x="1353312" y="2395728"/>
-            <a:ext cx="5029200" cy="530352"/>
+            <a:off x="1627632" y="2395728"/>
+            <a:ext cx="4206240" cy="786384"/>
           </a:xfrm>
           <a:prstGeom prst="rect">
             <a:avLst/>
@@ -4333,7 +4450,7 @@
               </a:spcAft>
             </a:pPr>
             <a:r>
-              <a:rPr sz="1200" b="0">
+              <a:rPr sz="1150" b="0">
                 <a:solidFill>
                   <a:srgbClr val="1A1A1A"/>
                 </a:solidFill>
@@ -4346,18 +4463,18 @@
       </p:sp>
       <p:sp>
         <p:nvSpPr>
-          <p:cNvPr id="9" name="Rounded Rectangle 8"/>
+          <p:cNvPr id="10" name="Rounded Rectangle 9"/>
           <p:cNvSpPr/>
           <p:nvPr/>
         </p:nvSpPr>
         <p:spPr>
           <a:xfrm>
-            <a:off x="841248" y="2999232"/>
-            <a:ext cx="5715000" cy="530352"/>
+            <a:off x="6254496" y="2395728"/>
+            <a:ext cx="5138928" cy="786384"/>
           </a:xfrm>
           <a:prstGeom prst="roundRect">
             <a:avLst>
-              <a:gd name="adj" fmla="val 6000"/>
+              <a:gd name="adj" fmla="val 7000"/>
             </a:avLst>
           </a:prstGeom>
           <a:solidFill>
@@ -4392,9 +4509,55 @@
           </a:p>
         </p:txBody>
       </p:sp>
+      <p:sp>
+        <p:nvSpPr>
+          <p:cNvPr id="11" name="Rounded Rectangle 10"/>
+          <p:cNvSpPr/>
+          <p:nvPr/>
+        </p:nvSpPr>
+        <p:spPr>
+          <a:xfrm>
+            <a:off x="6400800" y="2532888"/>
+            <a:ext cx="512064" cy="512064"/>
+          </a:xfrm>
+          <a:prstGeom prst="roundRect">
+            <a:avLst>
+              <a:gd name="adj" fmla="val 26000"/>
+            </a:avLst>
+          </a:prstGeom>
+          <a:solidFill>
+            <a:srgbClr val="EE0000"/>
+          </a:solidFill>
+          <a:ln>
+            <a:noFill/>
+          </a:ln>
+          <a:effectLst/>
+        </p:spPr>
+        <p:style>
+          <a:lnRef idx="1">
+            <a:schemeClr val="accent1"/>
+          </a:lnRef>
+          <a:fillRef idx="3">
+            <a:schemeClr val="accent1"/>
+          </a:fillRef>
+          <a:effectRef idx="2">
+            <a:schemeClr val="accent1"/>
+          </a:effectRef>
+          <a:fontRef idx="minor">
+            <a:schemeClr val="lt1"/>
+          </a:fontRef>
+        </p:style>
+        <p:txBody>
+          <a:bodyPr rtlCol="0" anchor="ctr"/>
+          <a:lstStyle/>
+          <a:p>
+            <a:pPr algn="ctr"/>
+          </a:p>
+        </p:txBody>
+      </p:sp>
       <p:pic>
         <p:nvPicPr>
-          <p:cNvPr id="10" name="Picture 9" descr="check_steel.png"/>
+          <p:cNvPr id="12" name="Picture 11" descr="check_white.png"/>
           <p:cNvPicPr>
             <a:picLocks noChangeAspect="1"/>
           </p:cNvPicPr>
@@ -4408,8 +4571,8 @@
         </p:blipFill>
         <p:spPr>
           <a:xfrm>
-            <a:off x="987552" y="3145536"/>
-            <a:ext cx="237744" cy="237744"/>
+            <a:off x="6523695" y="2655783"/>
+            <a:ext cx="266273" cy="266273"/>
           </a:xfrm>
           <a:prstGeom prst="rect">
             <a:avLst/>
@@ -4418,14 +4581,14 @@
       </p:pic>
       <p:sp>
         <p:nvSpPr>
-          <p:cNvPr id="11" name="TextBox 10"/>
+          <p:cNvPr id="13" name="TextBox 12"/>
           <p:cNvSpPr txBox="1"/>
           <p:nvPr/>
         </p:nvSpPr>
         <p:spPr>
           <a:xfrm>
-            <a:off x="1353312" y="2999232"/>
-            <a:ext cx="5029200" cy="530352"/>
+            <a:off x="7040880" y="2395728"/>
+            <a:ext cx="4206240" cy="786384"/>
           </a:xfrm>
           <a:prstGeom prst="rect">
             <a:avLst/>
@@ -4450,7 +4613,7 @@
               </a:spcAft>
             </a:pPr>
             <a:r>
-              <a:rPr sz="1200" b="0">
+              <a:rPr sz="1150" b="0">
                 <a:solidFill>
                   <a:srgbClr val="1A1A1A"/>
                 </a:solidFill>
@@ -4463,18 +4626,18 @@
       </p:sp>
       <p:sp>
         <p:nvSpPr>
-          <p:cNvPr id="12" name="Rounded Rectangle 11"/>
+          <p:cNvPr id="14" name="Rounded Rectangle 13"/>
           <p:cNvSpPr/>
           <p:nvPr/>
         </p:nvSpPr>
         <p:spPr>
           <a:xfrm>
-            <a:off x="841248" y="3602736"/>
-            <a:ext cx="5715000" cy="530352"/>
+            <a:off x="841248" y="3328416"/>
+            <a:ext cx="5138928" cy="786384"/>
           </a:xfrm>
           <a:prstGeom prst="roundRect">
             <a:avLst>
-              <a:gd name="adj" fmla="val 6000"/>
+              <a:gd name="adj" fmla="val 7000"/>
             </a:avLst>
           </a:prstGeom>
           <a:solidFill>
@@ -4509,9 +4672,55 @@
           </a:p>
         </p:txBody>
       </p:sp>
+      <p:sp>
+        <p:nvSpPr>
+          <p:cNvPr id="15" name="Rounded Rectangle 14"/>
+          <p:cNvSpPr/>
+          <p:nvPr/>
+        </p:nvSpPr>
+        <p:spPr>
+          <a:xfrm>
+            <a:off x="987552" y="3465576"/>
+            <a:ext cx="512064" cy="512064"/>
+          </a:xfrm>
+          <a:prstGeom prst="roundRect">
+            <a:avLst>
+              <a:gd name="adj" fmla="val 26000"/>
+            </a:avLst>
+          </a:prstGeom>
+          <a:solidFill>
+            <a:srgbClr val="EE0000"/>
+          </a:solidFill>
+          <a:ln>
+            <a:noFill/>
+          </a:ln>
+          <a:effectLst/>
+        </p:spPr>
+        <p:style>
+          <a:lnRef idx="1">
+            <a:schemeClr val="accent1"/>
+          </a:lnRef>
+          <a:fillRef idx="3">
+            <a:schemeClr val="accent1"/>
+          </a:fillRef>
+          <a:effectRef idx="2">
+            <a:schemeClr val="accent1"/>
+          </a:effectRef>
+          <a:fontRef idx="minor">
+            <a:schemeClr val="lt1"/>
+          </a:fontRef>
+        </p:style>
+        <p:txBody>
+          <a:bodyPr rtlCol="0" anchor="ctr"/>
+          <a:lstStyle/>
+          <a:p>
+            <a:pPr algn="ctr"/>
+          </a:p>
+        </p:txBody>
+      </p:sp>
       <p:pic>
         <p:nvPicPr>
-          <p:cNvPr id="13" name="Picture 12" descr="check_steel.png"/>
+          <p:cNvPr id="16" name="Picture 15" descr="check_white.png"/>
           <p:cNvPicPr>
             <a:picLocks noChangeAspect="1"/>
           </p:cNvPicPr>
@@ -4525,8 +4734,8 @@
         </p:blipFill>
         <p:spPr>
           <a:xfrm>
-            <a:off x="987552" y="3749040"/>
-            <a:ext cx="237744" cy="237744"/>
+            <a:off x="1110447" y="3588471"/>
+            <a:ext cx="266273" cy="266273"/>
           </a:xfrm>
           <a:prstGeom prst="rect">
             <a:avLst/>
@@ -4535,14 +4744,14 @@
       </p:pic>
       <p:sp>
         <p:nvSpPr>
-          <p:cNvPr id="14" name="TextBox 13"/>
+          <p:cNvPr id="17" name="TextBox 16"/>
           <p:cNvSpPr txBox="1"/>
           <p:nvPr/>
         </p:nvSpPr>
         <p:spPr>
           <a:xfrm>
-            <a:off x="1353312" y="3602736"/>
-            <a:ext cx="5029200" cy="530352"/>
+            <a:off x="1627632" y="3328416"/>
+            <a:ext cx="4206240" cy="786384"/>
           </a:xfrm>
           <a:prstGeom prst="rect">
             <a:avLst/>
@@ -4567,7 +4776,7 @@
               </a:spcAft>
             </a:pPr>
             <a:r>
-              <a:rPr sz="1200" b="0">
+              <a:rPr sz="1150" b="0">
                 <a:solidFill>
                   <a:srgbClr val="1A1A1A"/>
                 </a:solidFill>
@@ -4580,18 +4789,18 @@
       </p:sp>
       <p:sp>
         <p:nvSpPr>
-          <p:cNvPr id="15" name="Rounded Rectangle 14"/>
+          <p:cNvPr id="18" name="Rounded Rectangle 17"/>
           <p:cNvSpPr/>
           <p:nvPr/>
         </p:nvSpPr>
         <p:spPr>
           <a:xfrm>
-            <a:off x="841248" y="4206240"/>
-            <a:ext cx="5715000" cy="530352"/>
+            <a:off x="6254496" y="3328416"/>
+            <a:ext cx="5138928" cy="786384"/>
           </a:xfrm>
           <a:prstGeom prst="roundRect">
             <a:avLst>
-              <a:gd name="adj" fmla="val 6000"/>
+              <a:gd name="adj" fmla="val 7000"/>
             </a:avLst>
           </a:prstGeom>
           <a:solidFill>
@@ -4626,9 +4835,55 @@
           </a:p>
         </p:txBody>
       </p:sp>
+      <p:sp>
+        <p:nvSpPr>
+          <p:cNvPr id="19" name="Rounded Rectangle 18"/>
+          <p:cNvSpPr/>
+          <p:nvPr/>
+        </p:nvSpPr>
+        <p:spPr>
+          <a:xfrm>
+            <a:off x="6400800" y="3465576"/>
+            <a:ext cx="512064" cy="512064"/>
+          </a:xfrm>
+          <a:prstGeom prst="roundRect">
+            <a:avLst>
+              <a:gd name="adj" fmla="val 26000"/>
+            </a:avLst>
+          </a:prstGeom>
+          <a:solidFill>
+            <a:srgbClr val="EE0000"/>
+          </a:solidFill>
+          <a:ln>
+            <a:noFill/>
+          </a:ln>
+          <a:effectLst/>
+        </p:spPr>
+        <p:style>
+          <a:lnRef idx="1">
+            <a:schemeClr val="accent1"/>
+          </a:lnRef>
+          <a:fillRef idx="3">
+            <a:schemeClr val="accent1"/>
+          </a:fillRef>
+          <a:effectRef idx="2">
+            <a:schemeClr val="accent1"/>
+          </a:effectRef>
+          <a:fontRef idx="minor">
+            <a:schemeClr val="lt1"/>
+          </a:fontRef>
+        </p:style>
+        <p:txBody>
+          <a:bodyPr rtlCol="0" anchor="ctr"/>
+          <a:lstStyle/>
+          <a:p>
+            <a:pPr algn="ctr"/>
+          </a:p>
+        </p:txBody>
+      </p:sp>
       <p:pic>
         <p:nvPicPr>
-          <p:cNvPr id="16" name="Picture 15" descr="check_steel.png"/>
+          <p:cNvPr id="20" name="Picture 19" descr="check_white.png"/>
           <p:cNvPicPr>
             <a:picLocks noChangeAspect="1"/>
           </p:cNvPicPr>
@@ -4642,8 +4897,8 @@
         </p:blipFill>
         <p:spPr>
           <a:xfrm>
-            <a:off x="987552" y="4352544"/>
-            <a:ext cx="237744" cy="237744"/>
+            <a:off x="6523695" y="3588471"/>
+            <a:ext cx="266273" cy="266273"/>
           </a:xfrm>
           <a:prstGeom prst="rect">
             <a:avLst/>
@@ -4652,14 +4907,14 @@
       </p:pic>
       <p:sp>
         <p:nvSpPr>
-          <p:cNvPr id="17" name="TextBox 16"/>
+          <p:cNvPr id="21" name="TextBox 20"/>
           <p:cNvSpPr txBox="1"/>
           <p:nvPr/>
         </p:nvSpPr>
         <p:spPr>
           <a:xfrm>
-            <a:off x="1353312" y="4206240"/>
-            <a:ext cx="5029200" cy="530352"/>
+            <a:off x="7040880" y="3328416"/>
+            <a:ext cx="4206240" cy="786384"/>
           </a:xfrm>
           <a:prstGeom prst="rect">
             <a:avLst/>
@@ -4684,7 +4939,7 @@
               </a:spcAft>
             </a:pPr>
             <a:r>
-              <a:rPr sz="1200" b="0">
+              <a:rPr sz="1150" b="0">
                 <a:solidFill>
                   <a:srgbClr val="1A1A1A"/>
                 </a:solidFill>
@@ -4697,18 +4952,18 @@
       </p:sp>
       <p:sp>
         <p:nvSpPr>
-          <p:cNvPr id="18" name="Rounded Rectangle 17"/>
+          <p:cNvPr id="22" name="Rounded Rectangle 21"/>
           <p:cNvSpPr/>
           <p:nvPr/>
         </p:nvSpPr>
         <p:spPr>
           <a:xfrm>
-            <a:off x="841248" y="4809744"/>
-            <a:ext cx="5715000" cy="530352"/>
+            <a:off x="841248" y="4261104"/>
+            <a:ext cx="5138928" cy="786384"/>
           </a:xfrm>
           <a:prstGeom prst="roundRect">
             <a:avLst>
-              <a:gd name="adj" fmla="val 6000"/>
+              <a:gd name="adj" fmla="val 7000"/>
             </a:avLst>
           </a:prstGeom>
           <a:solidFill>
@@ -4743,9 +4998,55 @@
           </a:p>
         </p:txBody>
       </p:sp>
+      <p:sp>
+        <p:nvSpPr>
+          <p:cNvPr id="23" name="Rounded Rectangle 22"/>
+          <p:cNvSpPr/>
+          <p:nvPr/>
+        </p:nvSpPr>
+        <p:spPr>
+          <a:xfrm>
+            <a:off x="987552" y="4398264"/>
+            <a:ext cx="512064" cy="512064"/>
+          </a:xfrm>
+          <a:prstGeom prst="roundRect">
+            <a:avLst>
+              <a:gd name="adj" fmla="val 26000"/>
+            </a:avLst>
+          </a:prstGeom>
+          <a:solidFill>
+            <a:srgbClr val="EE0000"/>
+          </a:solidFill>
+          <a:ln>
+            <a:noFill/>
+          </a:ln>
+          <a:effectLst/>
+        </p:spPr>
+        <p:style>
+          <a:lnRef idx="1">
+            <a:schemeClr val="accent1"/>
+          </a:lnRef>
+          <a:fillRef idx="3">
+            <a:schemeClr val="accent1"/>
+          </a:fillRef>
+          <a:effectRef idx="2">
+            <a:schemeClr val="accent1"/>
+          </a:effectRef>
+          <a:fontRef idx="minor">
+            <a:schemeClr val="lt1"/>
+          </a:fontRef>
+        </p:style>
+        <p:txBody>
+          <a:bodyPr rtlCol="0" anchor="ctr"/>
+          <a:lstStyle/>
+          <a:p>
+            <a:pPr algn="ctr"/>
+          </a:p>
+        </p:txBody>
+      </p:sp>
       <p:pic>
         <p:nvPicPr>
-          <p:cNvPr id="19" name="Picture 18" descr="check_steel.png"/>
+          <p:cNvPr id="24" name="Picture 23" descr="check_white.png"/>
           <p:cNvPicPr>
             <a:picLocks noChangeAspect="1"/>
           </p:cNvPicPr>
@@ -4759,8 +5060,8 @@
         </p:blipFill>
         <p:spPr>
           <a:xfrm>
-            <a:off x="987552" y="4956048"/>
-            <a:ext cx="237744" cy="237744"/>
+            <a:off x="1110447" y="4521159"/>
+            <a:ext cx="266273" cy="266273"/>
           </a:xfrm>
           <a:prstGeom prst="rect">
             <a:avLst/>
@@ -4769,14 +5070,14 @@
       </p:pic>
       <p:sp>
         <p:nvSpPr>
-          <p:cNvPr id="20" name="TextBox 19"/>
+          <p:cNvPr id="25" name="TextBox 24"/>
           <p:cNvSpPr txBox="1"/>
           <p:nvPr/>
         </p:nvSpPr>
         <p:spPr>
           <a:xfrm>
-            <a:off x="1353312" y="4809744"/>
-            <a:ext cx="5029200" cy="530352"/>
+            <a:off x="1627632" y="4261104"/>
+            <a:ext cx="4206240" cy="786384"/>
           </a:xfrm>
           <a:prstGeom prst="rect">
             <a:avLst/>
@@ -4801,221 +5102,13 @@
               </a:spcAft>
             </a:pPr>
             <a:r>
-              <a:rPr sz="1200" b="0">
+              <a:rPr sz="1150" b="0">
                 <a:solidFill>
                   <a:srgbClr val="1A1A1A"/>
                 </a:solidFill>
                 <a:latin typeface="Red Hat Text"/>
               </a:rPr>
               <a:t>There has to be a better model</a:t>
-            </a:r>
-          </a:p>
-        </p:txBody>
-      </p:sp>
-      <p:sp>
-        <p:nvSpPr>
-          <p:cNvPr id="21" name="Rounded Rectangle 20"/>
-          <p:cNvSpPr/>
-          <p:nvPr/>
-        </p:nvSpPr>
-        <p:spPr>
-          <a:xfrm>
-            <a:off x="6812280" y="2395728"/>
-            <a:ext cx="4538167" cy="2944368"/>
-          </a:xfrm>
-          <a:prstGeom prst="roundRect">
-            <a:avLst>
-              <a:gd name="adj" fmla="val 4000"/>
-            </a:avLst>
-          </a:prstGeom>
-          <a:solidFill>
-            <a:srgbClr val="FFFFFF"/>
-          </a:solidFill>
-          <a:ln w="15240">
-            <a:solidFill>
-              <a:srgbClr val="DDE1E6"/>
-            </a:solidFill>
-          </a:ln>
-          <a:effectLst/>
-        </p:spPr>
-        <p:style>
-          <a:lnRef idx="1">
-            <a:schemeClr val="accent1"/>
-          </a:lnRef>
-          <a:fillRef idx="3">
-            <a:schemeClr val="accent1"/>
-          </a:fillRef>
-          <a:effectRef idx="2">
-            <a:schemeClr val="accent1"/>
-          </a:effectRef>
-          <a:fontRef idx="minor">
-            <a:schemeClr val="lt1"/>
-          </a:fontRef>
-        </p:style>
-        <p:txBody>
-          <a:bodyPr rtlCol="0" anchor="ctr"/>
-          <a:lstStyle/>
-          <a:p>
-            <a:pPr algn="ctr"/>
-          </a:p>
-        </p:txBody>
-      </p:sp>
-      <p:sp>
-        <p:nvSpPr>
-          <p:cNvPr id="22" name="Rounded Rectangle 21"/>
-          <p:cNvSpPr/>
-          <p:nvPr/>
-        </p:nvSpPr>
-        <p:spPr>
-          <a:xfrm>
-            <a:off x="7013448" y="2596896"/>
-            <a:ext cx="1298448" cy="310896"/>
-          </a:xfrm>
-          <a:prstGeom prst="roundRect">
-            <a:avLst>
-              <a:gd name="adj" fmla="val 50000"/>
-            </a:avLst>
-          </a:prstGeom>
-          <a:solidFill>
-            <a:srgbClr val="FCECEC"/>
-          </a:solidFill>
-          <a:ln>
-            <a:noFill/>
-          </a:ln>
-          <a:effectLst/>
-        </p:spPr>
-        <p:style>
-          <a:lnRef idx="1">
-            <a:schemeClr val="accent1"/>
-          </a:lnRef>
-          <a:fillRef idx="3">
-            <a:schemeClr val="accent1"/>
-          </a:fillRef>
-          <a:effectRef idx="2">
-            <a:schemeClr val="accent1"/>
-          </a:effectRef>
-          <a:fontRef idx="minor">
-            <a:schemeClr val="lt1"/>
-          </a:fontRef>
-        </p:style>
-        <p:txBody>
-          <a:bodyPr rtlCol="0" anchor="ctr"/>
-          <a:lstStyle/>
-          <a:p>
-            <a:pPr algn="ctr"/>
-          </a:p>
-        </p:txBody>
-      </p:sp>
-      <p:sp>
-        <p:nvSpPr>
-          <p:cNvPr id="23" name="TextBox 22"/>
-          <p:cNvSpPr txBox="1"/>
-          <p:nvPr/>
-        </p:nvSpPr>
-        <p:spPr>
-          <a:xfrm>
-            <a:off x="7013448" y="2596896"/>
-            <a:ext cx="1298448" cy="310896"/>
-          </a:xfrm>
-          <a:prstGeom prst="rect">
-            <a:avLst/>
-          </a:prstGeom>
-          <a:noFill/>
-        </p:spPr>
-        <p:txBody>
-          <a:bodyPr wrap="none" anchor="ctr" lIns="0" rIns="0" tIns="0" bIns="0">
-            <a:spAutoFit/>
-          </a:bodyPr>
-          <a:lstStyle/>
-          <a:p>
-            <a:pPr algn="ctr">
-              <a:lnSpc>
-                <a:spcPct val="106000"/>
-              </a:lnSpc>
-              <a:spcBef>
-                <a:spcPts val="0"/>
-              </a:spcBef>
-              <a:spcAft>
-                <a:spcPts val="0"/>
-              </a:spcAft>
-            </a:pPr>
-            <a:r>
-              <a:rPr sz="850" b="1">
-                <a:solidFill>
-                  <a:srgbClr val="B80000"/>
-                </a:solidFill>
-                <a:latin typeface="Red Hat Display"/>
-              </a:rPr>
-              <a:t>MEDIA PASS</a:t>
-            </a:r>
-          </a:p>
-        </p:txBody>
-      </p:sp>
-      <p:pic>
-        <p:nvPicPr>
-          <p:cNvPr id="24" name="Picture 23" descr="eye_slate.png"/>
-          <p:cNvPicPr>
-            <a:picLocks noChangeAspect="1"/>
-          </p:cNvPicPr>
-          <p:nvPr/>
-        </p:nvPicPr>
-        <p:blipFill>
-          <a:blip r:embed="rId4"/>
-          <a:stretch>
-            <a:fillRect/>
-          </a:stretch>
-        </p:blipFill>
-        <p:spPr>
-          <a:xfrm>
-            <a:off x="8843619" y="3108960"/>
-            <a:ext cx="475488" cy="475488"/>
-          </a:xfrm>
-          <a:prstGeom prst="rect">
-            <a:avLst/>
-          </a:prstGeom>
-        </p:spPr>
-      </p:pic>
-      <p:sp>
-        <p:nvSpPr>
-          <p:cNvPr id="25" name="TextBox 24"/>
-          <p:cNvSpPr txBox="1"/>
-          <p:nvPr/>
-        </p:nvSpPr>
-        <p:spPr>
-          <a:xfrm>
-            <a:off x="7050024" y="3721608"/>
-            <a:ext cx="4062679" cy="1481328"/>
-          </a:xfrm>
-          <a:prstGeom prst="rect">
-            <a:avLst/>
-          </a:prstGeom>
-          <a:noFill/>
-        </p:spPr>
-        <p:txBody>
-          <a:bodyPr wrap="square" anchor="t" lIns="0" rIns="0" tIns="0" bIns="0">
-            <a:spAutoFit/>
-          </a:bodyPr>
-          <a:lstStyle/>
-          <a:p>
-            <a:pPr algn="l">
-              <a:lnSpc>
-                <a:spcPct val="120000"/>
-              </a:lnSpc>
-              <a:spcBef>
-                <a:spcPts val="0"/>
-              </a:spcBef>
-              <a:spcAft>
-                <a:spcPts val="0"/>
-              </a:spcAft>
-            </a:pPr>
-            <a:r>
-              <a:rPr sz="950" b="0">
-                <a:solidFill>
-                  <a:srgbClr val="8A9099"/>
-                </a:solidFill>
-                <a:latin typeface="Red Hat Text"/>
-              </a:rPr>
-              <a:t>Split image — a single labeled "pet" server with a pager, versus a herd of identical unnamed boxes.</a:t>
             </a:r>
           </a:p>
         </p:txBody>
@@ -5323,7 +5416,7 @@
         <p:spPr>
           <a:xfrm>
             <a:off x="841248" y="2395728"/>
-            <a:ext cx="5715000" cy="530352"/>
+            <a:ext cx="4160520" cy="475488"/>
           </a:xfrm>
           <a:prstGeom prst="roundRect">
             <a:avLst>
@@ -5378,8 +5471,8 @@
         </p:blipFill>
         <p:spPr>
           <a:xfrm>
-            <a:off x="987552" y="2542032"/>
-            <a:ext cx="237744" cy="237744"/>
+            <a:off x="969264" y="2532888"/>
+            <a:ext cx="201168" cy="201168"/>
           </a:xfrm>
           <a:prstGeom prst="rect">
             <a:avLst/>
@@ -5394,8 +5487,8 @@
         </p:nvSpPr>
         <p:spPr>
           <a:xfrm>
-            <a:off x="1353312" y="2395728"/>
-            <a:ext cx="5029200" cy="530352"/>
+            <a:off x="1280160" y="2395728"/>
+            <a:ext cx="3593591" cy="475488"/>
           </a:xfrm>
           <a:prstGeom prst="rect">
             <a:avLst/>
@@ -5420,7 +5513,7 @@
               </a:spcAft>
             </a:pPr>
             <a:r>
-              <a:rPr sz="1200" b="0">
+              <a:rPr sz="1050" b="0">
                 <a:solidFill>
                   <a:srgbClr val="1A1A1A"/>
                 </a:solidFill>
@@ -5439,8 +5532,8 @@
         </p:nvSpPr>
         <p:spPr>
           <a:xfrm>
-            <a:off x="841248" y="2999232"/>
-            <a:ext cx="5715000" cy="530352"/>
+            <a:off x="841248" y="2944368"/>
+            <a:ext cx="4160520" cy="475488"/>
           </a:xfrm>
           <a:prstGeom prst="roundRect">
             <a:avLst>
@@ -5495,8 +5588,8 @@
         </p:blipFill>
         <p:spPr>
           <a:xfrm>
-            <a:off x="987552" y="3145536"/>
-            <a:ext cx="237744" cy="237744"/>
+            <a:off x="969264" y="3081528"/>
+            <a:ext cx="201168" cy="201168"/>
           </a:xfrm>
           <a:prstGeom prst="rect">
             <a:avLst/>
@@ -5511,8 +5604,8 @@
         </p:nvSpPr>
         <p:spPr>
           <a:xfrm>
-            <a:off x="1353312" y="2999232"/>
-            <a:ext cx="5029200" cy="530352"/>
+            <a:off x="1280160" y="2944368"/>
+            <a:ext cx="3593591" cy="475488"/>
           </a:xfrm>
           <a:prstGeom prst="rect">
             <a:avLst/>
@@ -5537,7 +5630,7 @@
               </a:spcAft>
             </a:pPr>
             <a:r>
-              <a:rPr sz="1200" b="0">
+              <a:rPr sz="1050" b="0">
                 <a:solidFill>
                   <a:srgbClr val="1A1A1A"/>
                 </a:solidFill>
@@ -5556,8 +5649,8 @@
         </p:nvSpPr>
         <p:spPr>
           <a:xfrm>
-            <a:off x="841248" y="3602736"/>
-            <a:ext cx="5715000" cy="530352"/>
+            <a:off x="841248" y="3493008"/>
+            <a:ext cx="4160520" cy="475488"/>
           </a:xfrm>
           <a:prstGeom prst="roundRect">
             <a:avLst>
@@ -5612,8 +5705,8 @@
         </p:blipFill>
         <p:spPr>
           <a:xfrm>
-            <a:off x="987552" y="3749040"/>
-            <a:ext cx="237744" cy="237744"/>
+            <a:off x="969264" y="3630168"/>
+            <a:ext cx="201168" cy="201168"/>
           </a:xfrm>
           <a:prstGeom prst="rect">
             <a:avLst/>
@@ -5628,8 +5721,8 @@
         </p:nvSpPr>
         <p:spPr>
           <a:xfrm>
-            <a:off x="1353312" y="3602736"/>
-            <a:ext cx="5029200" cy="530352"/>
+            <a:off x="1280160" y="3493008"/>
+            <a:ext cx="3593591" cy="475488"/>
           </a:xfrm>
           <a:prstGeom prst="rect">
             <a:avLst/>
@@ -5654,7 +5747,7 @@
               </a:spcAft>
             </a:pPr>
             <a:r>
-              <a:rPr sz="1200" b="0">
+              <a:rPr sz="1050" b="0">
                 <a:solidFill>
                   <a:srgbClr val="1A1A1A"/>
                 </a:solidFill>
@@ -5673,8 +5766,8 @@
         </p:nvSpPr>
         <p:spPr>
           <a:xfrm>
-            <a:off x="841248" y="4206240"/>
-            <a:ext cx="5715000" cy="530352"/>
+            <a:off x="841248" y="4041648"/>
+            <a:ext cx="4160520" cy="475488"/>
           </a:xfrm>
           <a:prstGeom prst="roundRect">
             <a:avLst>
@@ -5729,8 +5822,8 @@
         </p:blipFill>
         <p:spPr>
           <a:xfrm>
-            <a:off x="987552" y="4352544"/>
-            <a:ext cx="237744" cy="237744"/>
+            <a:off x="969264" y="4178807"/>
+            <a:ext cx="201168" cy="201168"/>
           </a:xfrm>
           <a:prstGeom prst="rect">
             <a:avLst/>
@@ -5745,8 +5838,8 @@
         </p:nvSpPr>
         <p:spPr>
           <a:xfrm>
-            <a:off x="1353312" y="4206240"/>
-            <a:ext cx="5029200" cy="530352"/>
+            <a:off x="1280160" y="4041648"/>
+            <a:ext cx="3593591" cy="475488"/>
           </a:xfrm>
           <a:prstGeom prst="rect">
             <a:avLst/>
@@ -5771,7 +5864,7 @@
               </a:spcAft>
             </a:pPr>
             <a:r>
-              <a:rPr sz="1200" b="0">
+              <a:rPr sz="1050" b="0">
                 <a:solidFill>
                   <a:srgbClr val="1A1A1A"/>
                 </a:solidFill>
@@ -5790,8 +5883,8 @@
         </p:nvSpPr>
         <p:spPr>
           <a:xfrm>
-            <a:off x="841248" y="4809744"/>
-            <a:ext cx="5715000" cy="530352"/>
+            <a:off x="841248" y="4590288"/>
+            <a:ext cx="4160520" cy="475488"/>
           </a:xfrm>
           <a:prstGeom prst="roundRect">
             <a:avLst>
@@ -5846,8 +5939,8 @@
         </p:blipFill>
         <p:spPr>
           <a:xfrm>
-            <a:off x="987552" y="4956048"/>
-            <a:ext cx="237744" cy="237744"/>
+            <a:off x="969264" y="4727447"/>
+            <a:ext cx="201168" cy="201168"/>
           </a:xfrm>
           <a:prstGeom prst="rect">
             <a:avLst/>
@@ -5862,8 +5955,8 @@
         </p:nvSpPr>
         <p:spPr>
           <a:xfrm>
-            <a:off x="1353312" y="4809744"/>
-            <a:ext cx="5029200" cy="530352"/>
+            <a:off x="1280160" y="4590288"/>
+            <a:ext cx="3593591" cy="475488"/>
           </a:xfrm>
           <a:prstGeom prst="rect">
             <a:avLst/>
@@ -5888,7 +5981,7 @@
               </a:spcAft>
             </a:pPr>
             <a:r>
-              <a:rPr sz="1200" b="0">
+              <a:rPr sz="1050" b="0">
                 <a:solidFill>
                   <a:srgbClr val="1A1A1A"/>
                 </a:solidFill>
@@ -5907,8 +6000,8 @@
         </p:nvSpPr>
         <p:spPr>
           <a:xfrm>
-            <a:off x="6812280" y="2395728"/>
-            <a:ext cx="4538167" cy="2944368"/>
+            <a:off x="5385816" y="2607149"/>
+            <a:ext cx="5964631" cy="2320356"/>
           </a:xfrm>
           <a:prstGeom prst="roundRect">
             <a:avLst>
@@ -5947,100 +6040,9 @@
           </a:p>
         </p:txBody>
       </p:sp>
-      <p:sp>
-        <p:nvSpPr>
-          <p:cNvPr id="22" name="Rounded Rectangle 21"/>
-          <p:cNvSpPr/>
-          <p:nvPr/>
-        </p:nvSpPr>
-        <p:spPr>
-          <a:xfrm>
-            <a:off x="7013448" y="2596896"/>
-            <a:ext cx="1298448" cy="310896"/>
-          </a:xfrm>
-          <a:prstGeom prst="roundRect">
-            <a:avLst>
-              <a:gd name="adj" fmla="val 50000"/>
-            </a:avLst>
-          </a:prstGeom>
-          <a:solidFill>
-            <a:srgbClr val="FCECEC"/>
-          </a:solidFill>
-          <a:ln>
-            <a:noFill/>
-          </a:ln>
-          <a:effectLst/>
-        </p:spPr>
-        <p:style>
-          <a:lnRef idx="1">
-            <a:schemeClr val="accent1"/>
-          </a:lnRef>
-          <a:fillRef idx="3">
-            <a:schemeClr val="accent1"/>
-          </a:fillRef>
-          <a:effectRef idx="2">
-            <a:schemeClr val="accent1"/>
-          </a:effectRef>
-          <a:fontRef idx="minor">
-            <a:schemeClr val="lt1"/>
-          </a:fontRef>
-        </p:style>
-        <p:txBody>
-          <a:bodyPr rtlCol="0" anchor="ctr"/>
-          <a:lstStyle/>
-          <a:p>
-            <a:pPr algn="ctr"/>
-          </a:p>
-        </p:txBody>
-      </p:sp>
-      <p:sp>
-        <p:nvSpPr>
-          <p:cNvPr id="23" name="TextBox 22"/>
-          <p:cNvSpPr txBox="1"/>
-          <p:nvPr/>
-        </p:nvSpPr>
-        <p:spPr>
-          <a:xfrm>
-            <a:off x="7013448" y="2596896"/>
-            <a:ext cx="1298448" cy="310896"/>
-          </a:xfrm>
-          <a:prstGeom prst="rect">
-            <a:avLst/>
-          </a:prstGeom>
-          <a:noFill/>
-        </p:spPr>
-        <p:txBody>
-          <a:bodyPr wrap="none" anchor="ctr" lIns="0" rIns="0" tIns="0" bIns="0">
-            <a:spAutoFit/>
-          </a:bodyPr>
-          <a:lstStyle/>
-          <a:p>
-            <a:pPr algn="ctr">
-              <a:lnSpc>
-                <a:spcPct val="106000"/>
-              </a:lnSpc>
-              <a:spcBef>
-                <a:spcPts val="0"/>
-              </a:spcBef>
-              <a:spcAft>
-                <a:spcPts val="0"/>
-              </a:spcAft>
-            </a:pPr>
-            <a:r>
-              <a:rPr sz="850" b="1">
-                <a:solidFill>
-                  <a:srgbClr val="B80000"/>
-                </a:solidFill>
-                <a:latin typeface="Red Hat Display"/>
-              </a:rPr>
-              <a:t>MEDIA PASS</a:t>
-            </a:r>
-          </a:p>
-        </p:txBody>
-      </p:sp>
       <p:pic>
         <p:nvPicPr>
-          <p:cNvPr id="24" name="Picture 23" descr="eye_slate.png"/>
+          <p:cNvPr id="22" name="Picture 21" descr="01-desired-state.png"/>
           <p:cNvPicPr>
             <a:picLocks noChangeAspect="1"/>
           </p:cNvPicPr>
@@ -6054,62 +6056,17 @@
         </p:blipFill>
         <p:spPr>
           <a:xfrm>
-            <a:off x="8843619" y="3108960"/>
-            <a:ext cx="475488" cy="475488"/>
+            <a:off x="5532120" y="2753453"/>
+            <a:ext cx="5672023" cy="2027748"/>
           </a:xfrm>
           <a:prstGeom prst="rect">
             <a:avLst/>
           </a:prstGeom>
         </p:spPr>
       </p:pic>
-      <p:sp>
-        <p:nvSpPr>
-          <p:cNvPr id="25" name="TextBox 24"/>
-          <p:cNvSpPr txBox="1"/>
-          <p:nvPr/>
-        </p:nvSpPr>
-        <p:spPr>
-          <a:xfrm>
-            <a:off x="7050024" y="3721608"/>
-            <a:ext cx="4062679" cy="1481328"/>
-          </a:xfrm>
-          <a:prstGeom prst="rect">
-            <a:avLst/>
-          </a:prstGeom>
-          <a:noFill/>
-        </p:spPr>
-        <p:txBody>
-          <a:bodyPr wrap="square" anchor="t" lIns="0" rIns="0" tIns="0" bIns="0">
-            <a:spAutoFit/>
-          </a:bodyPr>
-          <a:lstStyle/>
-          <a:p>
-            <a:pPr algn="l">
-              <a:lnSpc>
-                <a:spcPct val="120000"/>
-              </a:lnSpc>
-              <a:spcBef>
-                <a:spcPts val="0"/>
-              </a:spcBef>
-              <a:spcAft>
-                <a:spcPts val="0"/>
-              </a:spcAft>
-            </a:pPr>
-            <a:r>
-              <a:rPr sz="950" b="0">
-                <a:solidFill>
-                  <a:srgbClr val="8A9099"/>
-                </a:solidFill>
-                <a:latin typeface="Red Hat Text"/>
-              </a:rPr>
-              <a:t>Reuse concept diagram platform-orientation-...-01-desired-state.svg — You → Deployment → ReplicaSet → 3 Pods, Service load-balancing, reconcile loop watching.</a:t>
-            </a:r>
-          </a:p>
-        </p:txBody>
-      </p:sp>
       <p:cxnSp>
         <p:nvCxnSpPr>
-          <p:cNvPr id="26" name="Connector 25"/>
+          <p:cNvPr id="23" name="Connector 22"/>
           <p:cNvCxnSpPr/>
           <p:nvPr/>
         </p:nvCxnSpPr>
@@ -6145,7 +6102,7 @@
       </p:cxnSp>
       <p:sp>
         <p:nvSpPr>
-          <p:cNvPr id="27" name="TextBox 26"/>
+          <p:cNvPr id="24" name="TextBox 23"/>
           <p:cNvSpPr txBox="1"/>
           <p:nvPr/>
         </p:nvSpPr>
@@ -6190,7 +6147,7 @@
       </p:sp>
       <p:sp>
         <p:nvSpPr>
-          <p:cNvPr id="28" name="TextBox 27"/>
+          <p:cNvPr id="25" name="TextBox 24"/>
           <p:cNvSpPr txBox="1"/>
           <p:nvPr/>
         </p:nvSpPr>
@@ -6410,7 +6367,7 @@
         <p:spPr>
           <a:xfrm>
             <a:off x="841248" y="2395728"/>
-            <a:ext cx="5715000" cy="530352"/>
+            <a:ext cx="4160520" cy="475488"/>
           </a:xfrm>
           <a:prstGeom prst="roundRect">
             <a:avLst>
@@ -6465,8 +6422,8 @@
         </p:blipFill>
         <p:spPr>
           <a:xfrm>
-            <a:off x="987552" y="2542032"/>
-            <a:ext cx="237744" cy="237744"/>
+            <a:off x="969264" y="2532888"/>
+            <a:ext cx="201168" cy="201168"/>
           </a:xfrm>
           <a:prstGeom prst="rect">
             <a:avLst/>
@@ -6481,8 +6438,8 @@
         </p:nvSpPr>
         <p:spPr>
           <a:xfrm>
-            <a:off x="1353312" y="2395728"/>
-            <a:ext cx="5029200" cy="530352"/>
+            <a:off x="1280160" y="2395728"/>
+            <a:ext cx="3593591" cy="475488"/>
           </a:xfrm>
           <a:prstGeom prst="rect">
             <a:avLst/>
@@ -6507,7 +6464,7 @@
               </a:spcAft>
             </a:pPr>
             <a:r>
-              <a:rPr sz="1200" b="0">
+              <a:rPr sz="1050" b="0">
                 <a:solidFill>
                   <a:srgbClr val="1A1A1A"/>
                 </a:solidFill>
@@ -6526,8 +6483,8 @@
         </p:nvSpPr>
         <p:spPr>
           <a:xfrm>
-            <a:off x="841248" y="2999232"/>
-            <a:ext cx="5715000" cy="530352"/>
+            <a:off x="841248" y="2944368"/>
+            <a:ext cx="4160520" cy="475488"/>
           </a:xfrm>
           <a:prstGeom prst="roundRect">
             <a:avLst>
@@ -6582,8 +6539,8 @@
         </p:blipFill>
         <p:spPr>
           <a:xfrm>
-            <a:off x="987552" y="3145536"/>
-            <a:ext cx="237744" cy="237744"/>
+            <a:off x="969264" y="3081528"/>
+            <a:ext cx="201168" cy="201168"/>
           </a:xfrm>
           <a:prstGeom prst="rect">
             <a:avLst/>
@@ -6598,8 +6555,8 @@
         </p:nvSpPr>
         <p:spPr>
           <a:xfrm>
-            <a:off x="1353312" y="2999232"/>
-            <a:ext cx="5029200" cy="530352"/>
+            <a:off x="1280160" y="2944368"/>
+            <a:ext cx="3593591" cy="475488"/>
           </a:xfrm>
           <a:prstGeom prst="rect">
             <a:avLst/>
@@ -6624,7 +6581,7 @@
               </a:spcAft>
             </a:pPr>
             <a:r>
-              <a:rPr sz="1200" b="0">
+              <a:rPr sz="1050" b="0">
                 <a:solidFill>
                   <a:srgbClr val="1A1A1A"/>
                 </a:solidFill>
@@ -6643,8 +6600,8 @@
         </p:nvSpPr>
         <p:spPr>
           <a:xfrm>
-            <a:off x="841248" y="3602736"/>
-            <a:ext cx="5715000" cy="530352"/>
+            <a:off x="841248" y="3493008"/>
+            <a:ext cx="4160520" cy="475488"/>
           </a:xfrm>
           <a:prstGeom prst="roundRect">
             <a:avLst>
@@ -6699,8 +6656,8 @@
         </p:blipFill>
         <p:spPr>
           <a:xfrm>
-            <a:off x="987552" y="3749040"/>
-            <a:ext cx="237744" cy="237744"/>
+            <a:off x="969264" y="3630168"/>
+            <a:ext cx="201168" cy="201168"/>
           </a:xfrm>
           <a:prstGeom prst="rect">
             <a:avLst/>
@@ -6715,8 +6672,8 @@
         </p:nvSpPr>
         <p:spPr>
           <a:xfrm>
-            <a:off x="1353312" y="3602736"/>
-            <a:ext cx="5029200" cy="530352"/>
+            <a:off x="1280160" y="3493008"/>
+            <a:ext cx="3593591" cy="475488"/>
           </a:xfrm>
           <a:prstGeom prst="rect">
             <a:avLst/>
@@ -6741,7 +6698,7 @@
               </a:spcAft>
             </a:pPr>
             <a:r>
-              <a:rPr sz="1200" b="0">
+              <a:rPr sz="1050" b="0">
                 <a:solidFill>
                   <a:srgbClr val="1A1A1A"/>
                 </a:solidFill>
@@ -6760,8 +6717,8 @@
         </p:nvSpPr>
         <p:spPr>
           <a:xfrm>
-            <a:off x="841248" y="4206240"/>
-            <a:ext cx="5715000" cy="530352"/>
+            <a:off x="841248" y="4041648"/>
+            <a:ext cx="4160520" cy="475488"/>
           </a:xfrm>
           <a:prstGeom prst="roundRect">
             <a:avLst>
@@ -6816,8 +6773,8 @@
         </p:blipFill>
         <p:spPr>
           <a:xfrm>
-            <a:off x="987552" y="4352544"/>
-            <a:ext cx="237744" cy="237744"/>
+            <a:off x="969264" y="4178807"/>
+            <a:ext cx="201168" cy="201168"/>
           </a:xfrm>
           <a:prstGeom prst="rect">
             <a:avLst/>
@@ -6832,8 +6789,8 @@
         </p:nvSpPr>
         <p:spPr>
           <a:xfrm>
-            <a:off x="1353312" y="4206240"/>
-            <a:ext cx="5029200" cy="530352"/>
+            <a:off x="1280160" y="4041648"/>
+            <a:ext cx="3593591" cy="475488"/>
           </a:xfrm>
           <a:prstGeom prst="rect">
             <a:avLst/>
@@ -6858,7 +6815,7 @@
               </a:spcAft>
             </a:pPr>
             <a:r>
-              <a:rPr sz="1200" b="0">
+              <a:rPr sz="1050" b="0">
                 <a:solidFill>
                   <a:srgbClr val="1A1A1A"/>
                 </a:solidFill>
@@ -6877,8 +6834,8 @@
         </p:nvSpPr>
         <p:spPr>
           <a:xfrm>
-            <a:off x="841248" y="4809744"/>
-            <a:ext cx="5715000" cy="530352"/>
+            <a:off x="841248" y="4590288"/>
+            <a:ext cx="4160520" cy="475488"/>
           </a:xfrm>
           <a:prstGeom prst="roundRect">
             <a:avLst>
@@ -6933,8 +6890,8 @@
         </p:blipFill>
         <p:spPr>
           <a:xfrm>
-            <a:off x="987552" y="4956048"/>
-            <a:ext cx="237744" cy="237744"/>
+            <a:off x="969264" y="4727447"/>
+            <a:ext cx="201168" cy="201168"/>
           </a:xfrm>
           <a:prstGeom prst="rect">
             <a:avLst/>
@@ -6949,8 +6906,8 @@
         </p:nvSpPr>
         <p:spPr>
           <a:xfrm>
-            <a:off x="1353312" y="4809744"/>
-            <a:ext cx="5029200" cy="530352"/>
+            <a:off x="1280160" y="4590288"/>
+            <a:ext cx="3593591" cy="475488"/>
           </a:xfrm>
           <a:prstGeom prst="rect">
             <a:avLst/>
@@ -6975,7 +6932,7 @@
               </a:spcAft>
             </a:pPr>
             <a:r>
-              <a:rPr sz="1200" b="0">
+              <a:rPr sz="1050" b="0">
                 <a:solidFill>
                   <a:srgbClr val="1A1A1A"/>
                 </a:solidFill>
@@ -6994,8 +6951,8 @@
         </p:nvSpPr>
         <p:spPr>
           <a:xfrm>
-            <a:off x="6812280" y="2395728"/>
-            <a:ext cx="4538167" cy="2944368"/>
+            <a:off x="5385816" y="2395728"/>
+            <a:ext cx="5964631" cy="2806023"/>
           </a:xfrm>
           <a:prstGeom prst="roundRect">
             <a:avLst>
@@ -7034,100 +6991,9 @@
           </a:p>
         </p:txBody>
       </p:sp>
-      <p:sp>
-        <p:nvSpPr>
-          <p:cNvPr id="22" name="Rounded Rectangle 21"/>
-          <p:cNvSpPr/>
-          <p:nvPr/>
-        </p:nvSpPr>
-        <p:spPr>
-          <a:xfrm>
-            <a:off x="7013448" y="2596896"/>
-            <a:ext cx="1298448" cy="310896"/>
-          </a:xfrm>
-          <a:prstGeom prst="roundRect">
-            <a:avLst>
-              <a:gd name="adj" fmla="val 50000"/>
-            </a:avLst>
-          </a:prstGeom>
-          <a:solidFill>
-            <a:srgbClr val="FCECEC"/>
-          </a:solidFill>
-          <a:ln>
-            <a:noFill/>
-          </a:ln>
-          <a:effectLst/>
-        </p:spPr>
-        <p:style>
-          <a:lnRef idx="1">
-            <a:schemeClr val="accent1"/>
-          </a:lnRef>
-          <a:fillRef idx="3">
-            <a:schemeClr val="accent1"/>
-          </a:fillRef>
-          <a:effectRef idx="2">
-            <a:schemeClr val="accent1"/>
-          </a:effectRef>
-          <a:fontRef idx="minor">
-            <a:schemeClr val="lt1"/>
-          </a:fontRef>
-        </p:style>
-        <p:txBody>
-          <a:bodyPr rtlCol="0" anchor="ctr"/>
-          <a:lstStyle/>
-          <a:p>
-            <a:pPr algn="ctr"/>
-          </a:p>
-        </p:txBody>
-      </p:sp>
-      <p:sp>
-        <p:nvSpPr>
-          <p:cNvPr id="23" name="TextBox 22"/>
-          <p:cNvSpPr txBox="1"/>
-          <p:nvPr/>
-        </p:nvSpPr>
-        <p:spPr>
-          <a:xfrm>
-            <a:off x="7013448" y="2596896"/>
-            <a:ext cx="1298448" cy="310896"/>
-          </a:xfrm>
-          <a:prstGeom prst="rect">
-            <a:avLst/>
-          </a:prstGeom>
-          <a:noFill/>
-        </p:spPr>
-        <p:txBody>
-          <a:bodyPr wrap="none" anchor="ctr" lIns="0" rIns="0" tIns="0" bIns="0">
-            <a:spAutoFit/>
-          </a:bodyPr>
-          <a:lstStyle/>
-          <a:p>
-            <a:pPr algn="ctr">
-              <a:lnSpc>
-                <a:spcPct val="106000"/>
-              </a:lnSpc>
-              <a:spcBef>
-                <a:spcPts val="0"/>
-              </a:spcBef>
-              <a:spcAft>
-                <a:spcPts val="0"/>
-              </a:spcAft>
-            </a:pPr>
-            <a:r>
-              <a:rPr sz="850" b="1">
-                <a:solidFill>
-                  <a:srgbClr val="B80000"/>
-                </a:solidFill>
-                <a:latin typeface="Red Hat Display"/>
-              </a:rPr>
-              <a:t>MEDIA PASS</a:t>
-            </a:r>
-          </a:p>
-        </p:txBody>
-      </p:sp>
       <p:pic>
         <p:nvPicPr>
-          <p:cNvPr id="24" name="Picture 23" descr="eye_slate.png"/>
+          <p:cNvPr id="22" name="Picture 21" descr="02-platform-accretion-v1.png"/>
           <p:cNvPicPr>
             <a:picLocks noChangeAspect="1"/>
           </p:cNvPicPr>
@@ -7141,62 +7007,17 @@
         </p:blipFill>
         <p:spPr>
           <a:xfrm>
-            <a:off x="8843619" y="3108960"/>
-            <a:ext cx="475488" cy="475488"/>
+            <a:off x="5532120" y="2542032"/>
+            <a:ext cx="5672023" cy="2513415"/>
           </a:xfrm>
           <a:prstGeom prst="rect">
             <a:avLst/>
           </a:prstGeom>
         </p:spPr>
       </p:pic>
-      <p:sp>
-        <p:nvSpPr>
-          <p:cNvPr id="25" name="TextBox 24"/>
-          <p:cNvSpPr txBox="1"/>
-          <p:nvPr/>
-        </p:nvSpPr>
-        <p:spPr>
-          <a:xfrm>
-            <a:off x="7050024" y="3721608"/>
-            <a:ext cx="4062679" cy="1481328"/>
-          </a:xfrm>
-          <a:prstGeom prst="rect">
-            <a:avLst/>
-          </a:prstGeom>
-          <a:noFill/>
-        </p:spPr>
-        <p:txBody>
-          <a:bodyPr wrap="square" anchor="t" lIns="0" rIns="0" tIns="0" bIns="0">
-            <a:spAutoFit/>
-          </a:bodyPr>
-          <a:lstStyle/>
-          <a:p>
-            <a:pPr algn="l">
-              <a:lnSpc>
-                <a:spcPct val="120000"/>
-              </a:lnSpc>
-              <a:spcBef>
-                <a:spcPts val="0"/>
-              </a:spcBef>
-              <a:spcAft>
-                <a:spcPts val="0"/>
-              </a:spcAft>
-            </a:pPr>
-            <a:r>
-              <a:rPr sz="950" b="0">
-                <a:solidFill>
-                  <a:srgbClr val="8A9099"/>
-                </a:solidFill>
-                <a:latin typeface="Red Hat Text"/>
-              </a:rPr>
-              <a:t>The platform-accretion master diagram platform-orientation-...-02-platform-accretion-v1.svg with the Platform Orientation layer highlighted in red.</a:t>
-            </a:r>
-          </a:p>
-        </p:txBody>
-      </p:sp>
       <p:cxnSp>
         <p:nvCxnSpPr>
-          <p:cNvPr id="26" name="Connector 25"/>
+          <p:cNvPr id="23" name="Connector 22"/>
           <p:cNvCxnSpPr/>
           <p:nvPr/>
         </p:nvCxnSpPr>
@@ -7232,7 +7053,7 @@
       </p:cxnSp>
       <p:sp>
         <p:nvSpPr>
-          <p:cNvPr id="27" name="TextBox 26"/>
+          <p:cNvPr id="24" name="TextBox 23"/>
           <p:cNvSpPr txBox="1"/>
           <p:nvPr/>
         </p:nvSpPr>
@@ -7277,7 +7098,7 @@
       </p:sp>
       <p:sp>
         <p:nvSpPr>
-          <p:cNvPr id="28" name="TextBox 27"/>
+          <p:cNvPr id="25" name="TextBox 24"/>
           <p:cNvSpPr txBox="1"/>
           <p:nvPr/>
         </p:nvSpPr>
@@ -7497,11 +7318,11 @@
         <p:spPr>
           <a:xfrm>
             <a:off x="841248" y="2395728"/>
-            <a:ext cx="5715000" cy="530352"/>
+            <a:ext cx="5138928" cy="786384"/>
           </a:xfrm>
           <a:prstGeom prst="roundRect">
             <a:avLst>
-              <a:gd name="adj" fmla="val 6000"/>
+              <a:gd name="adj" fmla="val 7000"/>
             </a:avLst>
           </a:prstGeom>
           <a:solidFill>
@@ -7536,9 +7357,55 @@
           </a:p>
         </p:txBody>
       </p:sp>
+      <p:sp>
+        <p:nvSpPr>
+          <p:cNvPr id="7" name="Rounded Rectangle 6"/>
+          <p:cNvSpPr/>
+          <p:nvPr/>
+        </p:nvSpPr>
+        <p:spPr>
+          <a:xfrm>
+            <a:off x="987552" y="2532888"/>
+            <a:ext cx="512064" cy="512064"/>
+          </a:xfrm>
+          <a:prstGeom prst="roundRect">
+            <a:avLst>
+              <a:gd name="adj" fmla="val 26000"/>
+            </a:avLst>
+          </a:prstGeom>
+          <a:solidFill>
+            <a:srgbClr val="EE0000"/>
+          </a:solidFill>
+          <a:ln>
+            <a:noFill/>
+          </a:ln>
+          <a:effectLst/>
+        </p:spPr>
+        <p:style>
+          <a:lnRef idx="1">
+            <a:schemeClr val="accent1"/>
+          </a:lnRef>
+          <a:fillRef idx="3">
+            <a:schemeClr val="accent1"/>
+          </a:fillRef>
+          <a:effectRef idx="2">
+            <a:schemeClr val="accent1"/>
+          </a:effectRef>
+          <a:fontRef idx="minor">
+            <a:schemeClr val="lt1"/>
+          </a:fontRef>
+        </p:style>
+        <p:txBody>
+          <a:bodyPr rtlCol="0" anchor="ctr"/>
+          <a:lstStyle/>
+          <a:p>
+            <a:pPr algn="ctr"/>
+          </a:p>
+        </p:txBody>
+      </p:sp>
       <p:pic>
         <p:nvPicPr>
-          <p:cNvPr id="7" name="Picture 6" descr="check_steel.png"/>
+          <p:cNvPr id="8" name="Picture 7" descr="check_white.png"/>
           <p:cNvPicPr>
             <a:picLocks noChangeAspect="1"/>
           </p:cNvPicPr>
@@ -7552,8 +7419,8 @@
         </p:blipFill>
         <p:spPr>
           <a:xfrm>
-            <a:off x="987552" y="2542032"/>
-            <a:ext cx="237744" cy="237744"/>
+            <a:off x="1110447" y="2655783"/>
+            <a:ext cx="266273" cy="266273"/>
           </a:xfrm>
           <a:prstGeom prst="rect">
             <a:avLst/>
@@ -7562,14 +7429,14 @@
       </p:pic>
       <p:sp>
         <p:nvSpPr>
-          <p:cNvPr id="8" name="TextBox 7"/>
+          <p:cNvPr id="9" name="TextBox 8"/>
           <p:cNvSpPr txBox="1"/>
           <p:nvPr/>
         </p:nvSpPr>
         <p:spPr>
           <a:xfrm>
-            <a:off x="1353312" y="2395728"/>
-            <a:ext cx="5029200" cy="530352"/>
+            <a:off x="1627632" y="2395728"/>
+            <a:ext cx="4206240" cy="786384"/>
           </a:xfrm>
           <a:prstGeom prst="rect">
             <a:avLst/>
@@ -7594,7 +7461,7 @@
               </a:spcAft>
             </a:pPr>
             <a:r>
-              <a:rPr sz="1200" b="0">
+              <a:rPr sz="1150" b="0">
                 <a:solidFill>
                   <a:srgbClr val="1A1A1A"/>
                 </a:solidFill>
@@ -7607,18 +7474,18 @@
       </p:sp>
       <p:sp>
         <p:nvSpPr>
-          <p:cNvPr id="9" name="Rounded Rectangle 8"/>
+          <p:cNvPr id="10" name="Rounded Rectangle 9"/>
           <p:cNvSpPr/>
           <p:nvPr/>
         </p:nvSpPr>
         <p:spPr>
           <a:xfrm>
-            <a:off x="841248" y="2999232"/>
-            <a:ext cx="5715000" cy="530352"/>
+            <a:off x="6254496" y="2395728"/>
+            <a:ext cx="5138928" cy="786384"/>
           </a:xfrm>
           <a:prstGeom prst="roundRect">
             <a:avLst>
-              <a:gd name="adj" fmla="val 6000"/>
+              <a:gd name="adj" fmla="val 7000"/>
             </a:avLst>
           </a:prstGeom>
           <a:solidFill>
@@ -7653,9 +7520,55 @@
           </a:p>
         </p:txBody>
       </p:sp>
+      <p:sp>
+        <p:nvSpPr>
+          <p:cNvPr id="11" name="Rounded Rectangle 10"/>
+          <p:cNvSpPr/>
+          <p:nvPr/>
+        </p:nvSpPr>
+        <p:spPr>
+          <a:xfrm>
+            <a:off x="6400800" y="2532888"/>
+            <a:ext cx="512064" cy="512064"/>
+          </a:xfrm>
+          <a:prstGeom prst="roundRect">
+            <a:avLst>
+              <a:gd name="adj" fmla="val 26000"/>
+            </a:avLst>
+          </a:prstGeom>
+          <a:solidFill>
+            <a:srgbClr val="EE0000"/>
+          </a:solidFill>
+          <a:ln>
+            <a:noFill/>
+          </a:ln>
+          <a:effectLst/>
+        </p:spPr>
+        <p:style>
+          <a:lnRef idx="1">
+            <a:schemeClr val="accent1"/>
+          </a:lnRef>
+          <a:fillRef idx="3">
+            <a:schemeClr val="accent1"/>
+          </a:fillRef>
+          <a:effectRef idx="2">
+            <a:schemeClr val="accent1"/>
+          </a:effectRef>
+          <a:fontRef idx="minor">
+            <a:schemeClr val="lt1"/>
+          </a:fontRef>
+        </p:style>
+        <p:txBody>
+          <a:bodyPr rtlCol="0" anchor="ctr"/>
+          <a:lstStyle/>
+          <a:p>
+            <a:pPr algn="ctr"/>
+          </a:p>
+        </p:txBody>
+      </p:sp>
       <p:pic>
         <p:nvPicPr>
-          <p:cNvPr id="10" name="Picture 9" descr="check_steel.png"/>
+          <p:cNvPr id="12" name="Picture 11" descr="check_white.png"/>
           <p:cNvPicPr>
             <a:picLocks noChangeAspect="1"/>
           </p:cNvPicPr>
@@ -7669,8 +7582,8 @@
         </p:blipFill>
         <p:spPr>
           <a:xfrm>
-            <a:off x="987552" y="3145536"/>
-            <a:ext cx="237744" cy="237744"/>
+            <a:off x="6523695" y="2655783"/>
+            <a:ext cx="266273" cy="266273"/>
           </a:xfrm>
           <a:prstGeom prst="rect">
             <a:avLst/>
@@ -7679,14 +7592,14 @@
       </p:pic>
       <p:sp>
         <p:nvSpPr>
-          <p:cNvPr id="11" name="TextBox 10"/>
+          <p:cNvPr id="13" name="TextBox 12"/>
           <p:cNvSpPr txBox="1"/>
           <p:nvPr/>
         </p:nvSpPr>
         <p:spPr>
           <a:xfrm>
-            <a:off x="1353312" y="2999232"/>
-            <a:ext cx="5029200" cy="530352"/>
+            <a:off x="7040880" y="2395728"/>
+            <a:ext cx="4206240" cy="786384"/>
           </a:xfrm>
           <a:prstGeom prst="rect">
             <a:avLst/>
@@ -7711,7 +7624,7 @@
               </a:spcAft>
             </a:pPr>
             <a:r>
-              <a:rPr sz="1200" b="0">
+              <a:rPr sz="1150" b="0">
                 <a:solidFill>
                   <a:srgbClr val="1A1A1A"/>
                 </a:solidFill>
@@ -7724,18 +7637,18 @@
       </p:sp>
       <p:sp>
         <p:nvSpPr>
-          <p:cNvPr id="12" name="Rounded Rectangle 11"/>
+          <p:cNvPr id="14" name="Rounded Rectangle 13"/>
           <p:cNvSpPr/>
           <p:nvPr/>
         </p:nvSpPr>
         <p:spPr>
           <a:xfrm>
-            <a:off x="841248" y="3602736"/>
-            <a:ext cx="5715000" cy="530352"/>
+            <a:off x="841248" y="3328416"/>
+            <a:ext cx="5138928" cy="786384"/>
           </a:xfrm>
           <a:prstGeom prst="roundRect">
             <a:avLst>
-              <a:gd name="adj" fmla="val 6000"/>
+              <a:gd name="adj" fmla="val 7000"/>
             </a:avLst>
           </a:prstGeom>
           <a:solidFill>
@@ -7770,9 +7683,55 @@
           </a:p>
         </p:txBody>
       </p:sp>
+      <p:sp>
+        <p:nvSpPr>
+          <p:cNvPr id="15" name="Rounded Rectangle 14"/>
+          <p:cNvSpPr/>
+          <p:nvPr/>
+        </p:nvSpPr>
+        <p:spPr>
+          <a:xfrm>
+            <a:off x="987552" y="3465576"/>
+            <a:ext cx="512064" cy="512064"/>
+          </a:xfrm>
+          <a:prstGeom prst="roundRect">
+            <a:avLst>
+              <a:gd name="adj" fmla="val 26000"/>
+            </a:avLst>
+          </a:prstGeom>
+          <a:solidFill>
+            <a:srgbClr val="EE0000"/>
+          </a:solidFill>
+          <a:ln>
+            <a:noFill/>
+          </a:ln>
+          <a:effectLst/>
+        </p:spPr>
+        <p:style>
+          <a:lnRef idx="1">
+            <a:schemeClr val="accent1"/>
+          </a:lnRef>
+          <a:fillRef idx="3">
+            <a:schemeClr val="accent1"/>
+          </a:fillRef>
+          <a:effectRef idx="2">
+            <a:schemeClr val="accent1"/>
+          </a:effectRef>
+          <a:fontRef idx="minor">
+            <a:schemeClr val="lt1"/>
+          </a:fontRef>
+        </p:style>
+        <p:txBody>
+          <a:bodyPr rtlCol="0" anchor="ctr"/>
+          <a:lstStyle/>
+          <a:p>
+            <a:pPr algn="ctr"/>
+          </a:p>
+        </p:txBody>
+      </p:sp>
       <p:pic>
         <p:nvPicPr>
-          <p:cNvPr id="13" name="Picture 12" descr="check_steel.png"/>
+          <p:cNvPr id="16" name="Picture 15" descr="check_white.png"/>
           <p:cNvPicPr>
             <a:picLocks noChangeAspect="1"/>
           </p:cNvPicPr>
@@ -7786,8 +7745,8 @@
         </p:blipFill>
         <p:spPr>
           <a:xfrm>
-            <a:off x="987552" y="3749040"/>
-            <a:ext cx="237744" cy="237744"/>
+            <a:off x="1110447" y="3588471"/>
+            <a:ext cx="266273" cy="266273"/>
           </a:xfrm>
           <a:prstGeom prst="rect">
             <a:avLst/>
@@ -7796,14 +7755,14 @@
       </p:pic>
       <p:sp>
         <p:nvSpPr>
-          <p:cNvPr id="14" name="TextBox 13"/>
+          <p:cNvPr id="17" name="TextBox 16"/>
           <p:cNvSpPr txBox="1"/>
           <p:nvPr/>
         </p:nvSpPr>
         <p:spPr>
           <a:xfrm>
-            <a:off x="1353312" y="3602736"/>
-            <a:ext cx="5029200" cy="530352"/>
+            <a:off x="1627632" y="3328416"/>
+            <a:ext cx="4206240" cy="786384"/>
           </a:xfrm>
           <a:prstGeom prst="rect">
             <a:avLst/>
@@ -7828,7 +7787,7 @@
               </a:spcAft>
             </a:pPr>
             <a:r>
-              <a:rPr sz="1200" b="0">
+              <a:rPr sz="1150" b="0">
                 <a:solidFill>
                   <a:srgbClr val="1A1A1A"/>
                 </a:solidFill>
@@ -7841,18 +7800,18 @@
       </p:sp>
       <p:sp>
         <p:nvSpPr>
-          <p:cNvPr id="15" name="Rounded Rectangle 14"/>
+          <p:cNvPr id="18" name="Rounded Rectangle 17"/>
           <p:cNvSpPr/>
           <p:nvPr/>
         </p:nvSpPr>
         <p:spPr>
           <a:xfrm>
-            <a:off x="841248" y="4206240"/>
-            <a:ext cx="5715000" cy="530352"/>
+            <a:off x="6254496" y="3328416"/>
+            <a:ext cx="5138928" cy="786384"/>
           </a:xfrm>
           <a:prstGeom prst="roundRect">
             <a:avLst>
-              <a:gd name="adj" fmla="val 6000"/>
+              <a:gd name="adj" fmla="val 7000"/>
             </a:avLst>
           </a:prstGeom>
           <a:solidFill>
@@ -7887,9 +7846,55 @@
           </a:p>
         </p:txBody>
       </p:sp>
+      <p:sp>
+        <p:nvSpPr>
+          <p:cNvPr id="19" name="Rounded Rectangle 18"/>
+          <p:cNvSpPr/>
+          <p:nvPr/>
+        </p:nvSpPr>
+        <p:spPr>
+          <a:xfrm>
+            <a:off x="6400800" y="3465576"/>
+            <a:ext cx="512064" cy="512064"/>
+          </a:xfrm>
+          <a:prstGeom prst="roundRect">
+            <a:avLst>
+              <a:gd name="adj" fmla="val 26000"/>
+            </a:avLst>
+          </a:prstGeom>
+          <a:solidFill>
+            <a:srgbClr val="EE0000"/>
+          </a:solidFill>
+          <a:ln>
+            <a:noFill/>
+          </a:ln>
+          <a:effectLst/>
+        </p:spPr>
+        <p:style>
+          <a:lnRef idx="1">
+            <a:schemeClr val="accent1"/>
+          </a:lnRef>
+          <a:fillRef idx="3">
+            <a:schemeClr val="accent1"/>
+          </a:fillRef>
+          <a:effectRef idx="2">
+            <a:schemeClr val="accent1"/>
+          </a:effectRef>
+          <a:fontRef idx="minor">
+            <a:schemeClr val="lt1"/>
+          </a:fontRef>
+        </p:style>
+        <p:txBody>
+          <a:bodyPr rtlCol="0" anchor="ctr"/>
+          <a:lstStyle/>
+          <a:p>
+            <a:pPr algn="ctr"/>
+          </a:p>
+        </p:txBody>
+      </p:sp>
       <p:pic>
         <p:nvPicPr>
-          <p:cNvPr id="16" name="Picture 15" descr="check_steel.png"/>
+          <p:cNvPr id="20" name="Picture 19" descr="check_white.png"/>
           <p:cNvPicPr>
             <a:picLocks noChangeAspect="1"/>
           </p:cNvPicPr>
@@ -7903,8 +7908,8 @@
         </p:blipFill>
         <p:spPr>
           <a:xfrm>
-            <a:off x="987552" y="4352544"/>
-            <a:ext cx="237744" cy="237744"/>
+            <a:off x="6523695" y="3588471"/>
+            <a:ext cx="266273" cy="266273"/>
           </a:xfrm>
           <a:prstGeom prst="rect">
             <a:avLst/>
@@ -7913,14 +7918,14 @@
       </p:pic>
       <p:sp>
         <p:nvSpPr>
-          <p:cNvPr id="17" name="TextBox 16"/>
+          <p:cNvPr id="21" name="TextBox 20"/>
           <p:cNvSpPr txBox="1"/>
           <p:nvPr/>
         </p:nvSpPr>
         <p:spPr>
           <a:xfrm>
-            <a:off x="1353312" y="4206240"/>
-            <a:ext cx="5029200" cy="530352"/>
+            <a:off x="7040880" y="3328416"/>
+            <a:ext cx="4206240" cy="786384"/>
           </a:xfrm>
           <a:prstGeom prst="rect">
             <a:avLst/>
@@ -7945,7 +7950,7 @@
               </a:spcAft>
             </a:pPr>
             <a:r>
-              <a:rPr sz="1200" b="0">
+              <a:rPr sz="1150" b="0">
                 <a:solidFill>
                   <a:srgbClr val="1A1A1A"/>
                 </a:solidFill>
@@ -7958,18 +7963,18 @@
       </p:sp>
       <p:sp>
         <p:nvSpPr>
-          <p:cNvPr id="18" name="Rounded Rectangle 17"/>
+          <p:cNvPr id="22" name="Rounded Rectangle 21"/>
           <p:cNvSpPr/>
           <p:nvPr/>
         </p:nvSpPr>
         <p:spPr>
           <a:xfrm>
-            <a:off x="841248" y="4809744"/>
-            <a:ext cx="5715000" cy="530352"/>
+            <a:off x="841248" y="4261104"/>
+            <a:ext cx="5138928" cy="786384"/>
           </a:xfrm>
           <a:prstGeom prst="roundRect">
             <a:avLst>
-              <a:gd name="adj" fmla="val 6000"/>
+              <a:gd name="adj" fmla="val 7000"/>
             </a:avLst>
           </a:prstGeom>
           <a:solidFill>
@@ -8004,9 +8009,55 @@
           </a:p>
         </p:txBody>
       </p:sp>
+      <p:sp>
+        <p:nvSpPr>
+          <p:cNvPr id="23" name="Rounded Rectangle 22"/>
+          <p:cNvSpPr/>
+          <p:nvPr/>
+        </p:nvSpPr>
+        <p:spPr>
+          <a:xfrm>
+            <a:off x="987552" y="4398264"/>
+            <a:ext cx="512064" cy="512064"/>
+          </a:xfrm>
+          <a:prstGeom prst="roundRect">
+            <a:avLst>
+              <a:gd name="adj" fmla="val 26000"/>
+            </a:avLst>
+          </a:prstGeom>
+          <a:solidFill>
+            <a:srgbClr val="EE0000"/>
+          </a:solidFill>
+          <a:ln>
+            <a:noFill/>
+          </a:ln>
+          <a:effectLst/>
+        </p:spPr>
+        <p:style>
+          <a:lnRef idx="1">
+            <a:schemeClr val="accent1"/>
+          </a:lnRef>
+          <a:fillRef idx="3">
+            <a:schemeClr val="accent1"/>
+          </a:fillRef>
+          <a:effectRef idx="2">
+            <a:schemeClr val="accent1"/>
+          </a:effectRef>
+          <a:fontRef idx="minor">
+            <a:schemeClr val="lt1"/>
+          </a:fontRef>
+        </p:style>
+        <p:txBody>
+          <a:bodyPr rtlCol="0" anchor="ctr"/>
+          <a:lstStyle/>
+          <a:p>
+            <a:pPr algn="ctr"/>
+          </a:p>
+        </p:txBody>
+      </p:sp>
       <p:pic>
         <p:nvPicPr>
-          <p:cNvPr id="19" name="Picture 18" descr="check_steel.png"/>
+          <p:cNvPr id="24" name="Picture 23" descr="check_white.png"/>
           <p:cNvPicPr>
             <a:picLocks noChangeAspect="1"/>
           </p:cNvPicPr>
@@ -8020,8 +8071,8 @@
         </p:blipFill>
         <p:spPr>
           <a:xfrm>
-            <a:off x="987552" y="4956048"/>
-            <a:ext cx="237744" cy="237744"/>
+            <a:off x="1110447" y="4521159"/>
+            <a:ext cx="266273" cy="266273"/>
           </a:xfrm>
           <a:prstGeom prst="rect">
             <a:avLst/>
@@ -8030,14 +8081,14 @@
       </p:pic>
       <p:sp>
         <p:nvSpPr>
-          <p:cNvPr id="20" name="TextBox 19"/>
+          <p:cNvPr id="25" name="TextBox 24"/>
           <p:cNvSpPr txBox="1"/>
           <p:nvPr/>
         </p:nvSpPr>
         <p:spPr>
           <a:xfrm>
-            <a:off x="1353312" y="4809744"/>
-            <a:ext cx="5029200" cy="530352"/>
+            <a:off x="1627632" y="4261104"/>
+            <a:ext cx="4206240" cy="786384"/>
           </a:xfrm>
           <a:prstGeom prst="rect">
             <a:avLst/>
@@ -8062,221 +8113,13 @@
               </a:spcAft>
             </a:pPr>
             <a:r>
-              <a:rPr sz="1200" b="0">
+              <a:rPr sz="1150" b="0">
                 <a:solidFill>
                   <a:srgbClr val="1A1A1A"/>
                 </a:solidFill>
                 <a:latin typeface="Red Hat Text"/>
               </a:rPr>
               <a:t>Cattle, not pets</a:t>
-            </a:r>
-          </a:p>
-        </p:txBody>
-      </p:sp>
-      <p:sp>
-        <p:nvSpPr>
-          <p:cNvPr id="21" name="Rounded Rectangle 20"/>
-          <p:cNvSpPr/>
-          <p:nvPr/>
-        </p:nvSpPr>
-        <p:spPr>
-          <a:xfrm>
-            <a:off x="6812280" y="2395728"/>
-            <a:ext cx="4538167" cy="2944368"/>
-          </a:xfrm>
-          <a:prstGeom prst="roundRect">
-            <a:avLst>
-              <a:gd name="adj" fmla="val 4000"/>
-            </a:avLst>
-          </a:prstGeom>
-          <a:solidFill>
-            <a:srgbClr val="FFFFFF"/>
-          </a:solidFill>
-          <a:ln w="15240">
-            <a:solidFill>
-              <a:srgbClr val="DDE1E6"/>
-            </a:solidFill>
-          </a:ln>
-          <a:effectLst/>
-        </p:spPr>
-        <p:style>
-          <a:lnRef idx="1">
-            <a:schemeClr val="accent1"/>
-          </a:lnRef>
-          <a:fillRef idx="3">
-            <a:schemeClr val="accent1"/>
-          </a:fillRef>
-          <a:effectRef idx="2">
-            <a:schemeClr val="accent1"/>
-          </a:effectRef>
-          <a:fontRef idx="minor">
-            <a:schemeClr val="lt1"/>
-          </a:fontRef>
-        </p:style>
-        <p:txBody>
-          <a:bodyPr rtlCol="0" anchor="ctr"/>
-          <a:lstStyle/>
-          <a:p>
-            <a:pPr algn="ctr"/>
-          </a:p>
-        </p:txBody>
-      </p:sp>
-      <p:sp>
-        <p:nvSpPr>
-          <p:cNvPr id="22" name="Rounded Rectangle 21"/>
-          <p:cNvSpPr/>
-          <p:nvPr/>
-        </p:nvSpPr>
-        <p:spPr>
-          <a:xfrm>
-            <a:off x="7013448" y="2596896"/>
-            <a:ext cx="1298448" cy="310896"/>
-          </a:xfrm>
-          <a:prstGeom prst="roundRect">
-            <a:avLst>
-              <a:gd name="adj" fmla="val 50000"/>
-            </a:avLst>
-          </a:prstGeom>
-          <a:solidFill>
-            <a:srgbClr val="FCECEC"/>
-          </a:solidFill>
-          <a:ln>
-            <a:noFill/>
-          </a:ln>
-          <a:effectLst/>
-        </p:spPr>
-        <p:style>
-          <a:lnRef idx="1">
-            <a:schemeClr val="accent1"/>
-          </a:lnRef>
-          <a:fillRef idx="3">
-            <a:schemeClr val="accent1"/>
-          </a:fillRef>
-          <a:effectRef idx="2">
-            <a:schemeClr val="accent1"/>
-          </a:effectRef>
-          <a:fontRef idx="minor">
-            <a:schemeClr val="lt1"/>
-          </a:fontRef>
-        </p:style>
-        <p:txBody>
-          <a:bodyPr rtlCol="0" anchor="ctr"/>
-          <a:lstStyle/>
-          <a:p>
-            <a:pPr algn="ctr"/>
-          </a:p>
-        </p:txBody>
-      </p:sp>
-      <p:sp>
-        <p:nvSpPr>
-          <p:cNvPr id="23" name="TextBox 22"/>
-          <p:cNvSpPr txBox="1"/>
-          <p:nvPr/>
-        </p:nvSpPr>
-        <p:spPr>
-          <a:xfrm>
-            <a:off x="7013448" y="2596896"/>
-            <a:ext cx="1298448" cy="310896"/>
-          </a:xfrm>
-          <a:prstGeom prst="rect">
-            <a:avLst/>
-          </a:prstGeom>
-          <a:noFill/>
-        </p:spPr>
-        <p:txBody>
-          <a:bodyPr wrap="none" anchor="ctr" lIns="0" rIns="0" tIns="0" bIns="0">
-            <a:spAutoFit/>
-          </a:bodyPr>
-          <a:lstStyle/>
-          <a:p>
-            <a:pPr algn="ctr">
-              <a:lnSpc>
-                <a:spcPct val="106000"/>
-              </a:lnSpc>
-              <a:spcBef>
-                <a:spcPts val="0"/>
-              </a:spcBef>
-              <a:spcAft>
-                <a:spcPts val="0"/>
-              </a:spcAft>
-            </a:pPr>
-            <a:r>
-              <a:rPr sz="850" b="1">
-                <a:solidFill>
-                  <a:srgbClr val="B80000"/>
-                </a:solidFill>
-                <a:latin typeface="Red Hat Display"/>
-              </a:rPr>
-              <a:t>MEDIA PASS</a:t>
-            </a:r>
-          </a:p>
-        </p:txBody>
-      </p:sp>
-      <p:pic>
-        <p:nvPicPr>
-          <p:cNvPr id="24" name="Picture 23" descr="eye_slate.png"/>
-          <p:cNvPicPr>
-            <a:picLocks noChangeAspect="1"/>
-          </p:cNvPicPr>
-          <p:nvPr/>
-        </p:nvPicPr>
-        <p:blipFill>
-          <a:blip r:embed="rId4"/>
-          <a:stretch>
-            <a:fillRect/>
-          </a:stretch>
-        </p:blipFill>
-        <p:spPr>
-          <a:xfrm>
-            <a:off x="8843619" y="3108960"/>
-            <a:ext cx="475488" cy="475488"/>
-          </a:xfrm>
-          <a:prstGeom prst="rect">
-            <a:avLst/>
-          </a:prstGeom>
-        </p:spPr>
-      </p:pic>
-      <p:sp>
-        <p:nvSpPr>
-          <p:cNvPr id="25" name="TextBox 24"/>
-          <p:cNvSpPr txBox="1"/>
-          <p:nvPr/>
-        </p:nvSpPr>
-        <p:spPr>
-          <a:xfrm>
-            <a:off x="7050024" y="3721608"/>
-            <a:ext cx="4062679" cy="1481328"/>
-          </a:xfrm>
-          <a:prstGeom prst="rect">
-            <a:avLst/>
-          </a:prstGeom>
-          <a:noFill/>
-        </p:spPr>
-        <p:txBody>
-          <a:bodyPr wrap="square" anchor="t" lIns="0" rIns="0" tIns="0" bIns="0">
-            <a:spAutoFit/>
-          </a:bodyPr>
-          <a:lstStyle/>
-          <a:p>
-            <a:pPr algn="l">
-              <a:lnSpc>
-                <a:spcPct val="120000"/>
-              </a:lnSpc>
-              <a:spcBef>
-                <a:spcPts val="0"/>
-              </a:spcBef>
-              <a:spcAft>
-                <a:spcPts val="0"/>
-              </a:spcAft>
-            </a:pPr>
-            <a:r>
-              <a:rPr sz="950" b="0">
-                <a:solidFill>
-                  <a:srgbClr val="8A9099"/>
-                </a:solidFill>
-                <a:latin typeface="Red Hat Text"/>
-              </a:rPr>
-              <a:t>Screen-capture still or GIF platform-orientation-...-selfheal — Topology donut losing and regaining a segment.</a:t>
             </a:r>
           </a:p>
         </p:txBody>
@@ -8584,11 +8427,11 @@
         <p:spPr>
           <a:xfrm>
             <a:off x="841248" y="2395728"/>
-            <a:ext cx="5715000" cy="530352"/>
+            <a:ext cx="5138928" cy="786384"/>
           </a:xfrm>
           <a:prstGeom prst="roundRect">
             <a:avLst>
-              <a:gd name="adj" fmla="val 6000"/>
+              <a:gd name="adj" fmla="val 7000"/>
             </a:avLst>
           </a:prstGeom>
           <a:solidFill>
@@ -8623,9 +8466,55 @@
           </a:p>
         </p:txBody>
       </p:sp>
+      <p:sp>
+        <p:nvSpPr>
+          <p:cNvPr id="7" name="Rounded Rectangle 6"/>
+          <p:cNvSpPr/>
+          <p:nvPr/>
+        </p:nvSpPr>
+        <p:spPr>
+          <a:xfrm>
+            <a:off x="987552" y="2532888"/>
+            <a:ext cx="512064" cy="512064"/>
+          </a:xfrm>
+          <a:prstGeom prst="roundRect">
+            <a:avLst>
+              <a:gd name="adj" fmla="val 26000"/>
+            </a:avLst>
+          </a:prstGeom>
+          <a:solidFill>
+            <a:srgbClr val="EE0000"/>
+          </a:solidFill>
+          <a:ln>
+            <a:noFill/>
+          </a:ln>
+          <a:effectLst/>
+        </p:spPr>
+        <p:style>
+          <a:lnRef idx="1">
+            <a:schemeClr val="accent1"/>
+          </a:lnRef>
+          <a:fillRef idx="3">
+            <a:schemeClr val="accent1"/>
+          </a:fillRef>
+          <a:effectRef idx="2">
+            <a:schemeClr val="accent1"/>
+          </a:effectRef>
+          <a:fontRef idx="minor">
+            <a:schemeClr val="lt1"/>
+          </a:fontRef>
+        </p:style>
+        <p:txBody>
+          <a:bodyPr rtlCol="0" anchor="ctr"/>
+          <a:lstStyle/>
+          <a:p>
+            <a:pPr algn="ctr"/>
+          </a:p>
+        </p:txBody>
+      </p:sp>
       <p:pic>
         <p:nvPicPr>
-          <p:cNvPr id="7" name="Picture 6" descr="check_steel.png"/>
+          <p:cNvPr id="8" name="Picture 7" descr="check_white.png"/>
           <p:cNvPicPr>
             <a:picLocks noChangeAspect="1"/>
           </p:cNvPicPr>
@@ -8639,8 +8528,8 @@
         </p:blipFill>
         <p:spPr>
           <a:xfrm>
-            <a:off x="987552" y="2542032"/>
-            <a:ext cx="237744" cy="237744"/>
+            <a:off x="1110447" y="2655783"/>
+            <a:ext cx="266273" cy="266273"/>
           </a:xfrm>
           <a:prstGeom prst="rect">
             <a:avLst/>
@@ -8649,14 +8538,14 @@
       </p:pic>
       <p:sp>
         <p:nvSpPr>
-          <p:cNvPr id="8" name="TextBox 7"/>
+          <p:cNvPr id="9" name="TextBox 8"/>
           <p:cNvSpPr txBox="1"/>
           <p:nvPr/>
         </p:nvSpPr>
         <p:spPr>
           <a:xfrm>
-            <a:off x="1353312" y="2395728"/>
-            <a:ext cx="5029200" cy="530352"/>
+            <a:off x="1627632" y="2395728"/>
+            <a:ext cx="4206240" cy="786384"/>
           </a:xfrm>
           <a:prstGeom prst="rect">
             <a:avLst/>
@@ -8681,7 +8570,7 @@
               </a:spcAft>
             </a:pPr>
             <a:r>
-              <a:rPr sz="1200" b="0">
+              <a:rPr sz="1150" b="0">
                 <a:solidFill>
                   <a:srgbClr val="1A1A1A"/>
                 </a:solidFill>
@@ -8694,18 +8583,18 @@
       </p:sp>
       <p:sp>
         <p:nvSpPr>
-          <p:cNvPr id="9" name="Rounded Rectangle 8"/>
+          <p:cNvPr id="10" name="Rounded Rectangle 9"/>
           <p:cNvSpPr/>
           <p:nvPr/>
         </p:nvSpPr>
         <p:spPr>
           <a:xfrm>
-            <a:off x="841248" y="2999232"/>
-            <a:ext cx="5715000" cy="530352"/>
+            <a:off x="6254496" y="2395728"/>
+            <a:ext cx="5138928" cy="786384"/>
           </a:xfrm>
           <a:prstGeom prst="roundRect">
             <a:avLst>
-              <a:gd name="adj" fmla="val 6000"/>
+              <a:gd name="adj" fmla="val 7000"/>
             </a:avLst>
           </a:prstGeom>
           <a:solidFill>
@@ -8740,9 +8629,55 @@
           </a:p>
         </p:txBody>
       </p:sp>
+      <p:sp>
+        <p:nvSpPr>
+          <p:cNvPr id="11" name="Rounded Rectangle 10"/>
+          <p:cNvSpPr/>
+          <p:nvPr/>
+        </p:nvSpPr>
+        <p:spPr>
+          <a:xfrm>
+            <a:off x="6400800" y="2532888"/>
+            <a:ext cx="512064" cy="512064"/>
+          </a:xfrm>
+          <a:prstGeom prst="roundRect">
+            <a:avLst>
+              <a:gd name="adj" fmla="val 26000"/>
+            </a:avLst>
+          </a:prstGeom>
+          <a:solidFill>
+            <a:srgbClr val="EE0000"/>
+          </a:solidFill>
+          <a:ln>
+            <a:noFill/>
+          </a:ln>
+          <a:effectLst/>
+        </p:spPr>
+        <p:style>
+          <a:lnRef idx="1">
+            <a:schemeClr val="accent1"/>
+          </a:lnRef>
+          <a:fillRef idx="3">
+            <a:schemeClr val="accent1"/>
+          </a:fillRef>
+          <a:effectRef idx="2">
+            <a:schemeClr val="accent1"/>
+          </a:effectRef>
+          <a:fontRef idx="minor">
+            <a:schemeClr val="lt1"/>
+          </a:fontRef>
+        </p:style>
+        <p:txBody>
+          <a:bodyPr rtlCol="0" anchor="ctr"/>
+          <a:lstStyle/>
+          <a:p>
+            <a:pPr algn="ctr"/>
+          </a:p>
+        </p:txBody>
+      </p:sp>
       <p:pic>
         <p:nvPicPr>
-          <p:cNvPr id="10" name="Picture 9" descr="check_steel.png"/>
+          <p:cNvPr id="12" name="Picture 11" descr="check_white.png"/>
           <p:cNvPicPr>
             <a:picLocks noChangeAspect="1"/>
           </p:cNvPicPr>
@@ -8756,8 +8691,8 @@
         </p:blipFill>
         <p:spPr>
           <a:xfrm>
-            <a:off x="987552" y="3145536"/>
-            <a:ext cx="237744" cy="237744"/>
+            <a:off x="6523695" y="2655783"/>
+            <a:ext cx="266273" cy="266273"/>
           </a:xfrm>
           <a:prstGeom prst="rect">
             <a:avLst/>
@@ -8766,14 +8701,14 @@
       </p:pic>
       <p:sp>
         <p:nvSpPr>
-          <p:cNvPr id="11" name="TextBox 10"/>
+          <p:cNvPr id="13" name="TextBox 12"/>
           <p:cNvSpPr txBox="1"/>
           <p:nvPr/>
         </p:nvSpPr>
         <p:spPr>
           <a:xfrm>
-            <a:off x="1353312" y="2999232"/>
-            <a:ext cx="5029200" cy="530352"/>
+            <a:off x="7040880" y="2395728"/>
+            <a:ext cx="4206240" cy="786384"/>
           </a:xfrm>
           <a:prstGeom prst="rect">
             <a:avLst/>
@@ -8798,7 +8733,7 @@
               </a:spcAft>
             </a:pPr>
             <a:r>
-              <a:rPr sz="1200" b="0">
+              <a:rPr sz="1150" b="0">
                 <a:solidFill>
                   <a:srgbClr val="1A1A1A"/>
                 </a:solidFill>
@@ -8811,18 +8746,18 @@
       </p:sp>
       <p:sp>
         <p:nvSpPr>
-          <p:cNvPr id="12" name="Rounded Rectangle 11"/>
+          <p:cNvPr id="14" name="Rounded Rectangle 13"/>
           <p:cNvSpPr/>
           <p:nvPr/>
         </p:nvSpPr>
         <p:spPr>
           <a:xfrm>
-            <a:off x="841248" y="3602736"/>
-            <a:ext cx="5715000" cy="530352"/>
+            <a:off x="841248" y="3328416"/>
+            <a:ext cx="5138928" cy="786384"/>
           </a:xfrm>
           <a:prstGeom prst="roundRect">
             <a:avLst>
-              <a:gd name="adj" fmla="val 6000"/>
+              <a:gd name="adj" fmla="val 7000"/>
             </a:avLst>
           </a:prstGeom>
           <a:solidFill>
@@ -8857,9 +8792,55 @@
           </a:p>
         </p:txBody>
       </p:sp>
+      <p:sp>
+        <p:nvSpPr>
+          <p:cNvPr id="15" name="Rounded Rectangle 14"/>
+          <p:cNvSpPr/>
+          <p:nvPr/>
+        </p:nvSpPr>
+        <p:spPr>
+          <a:xfrm>
+            <a:off x="987552" y="3465576"/>
+            <a:ext cx="512064" cy="512064"/>
+          </a:xfrm>
+          <a:prstGeom prst="roundRect">
+            <a:avLst>
+              <a:gd name="adj" fmla="val 26000"/>
+            </a:avLst>
+          </a:prstGeom>
+          <a:solidFill>
+            <a:srgbClr val="EE0000"/>
+          </a:solidFill>
+          <a:ln>
+            <a:noFill/>
+          </a:ln>
+          <a:effectLst/>
+        </p:spPr>
+        <p:style>
+          <a:lnRef idx="1">
+            <a:schemeClr val="accent1"/>
+          </a:lnRef>
+          <a:fillRef idx="3">
+            <a:schemeClr val="accent1"/>
+          </a:fillRef>
+          <a:effectRef idx="2">
+            <a:schemeClr val="accent1"/>
+          </a:effectRef>
+          <a:fontRef idx="minor">
+            <a:schemeClr val="lt1"/>
+          </a:fontRef>
+        </p:style>
+        <p:txBody>
+          <a:bodyPr rtlCol="0" anchor="ctr"/>
+          <a:lstStyle/>
+          <a:p>
+            <a:pPr algn="ctr"/>
+          </a:p>
+        </p:txBody>
+      </p:sp>
       <p:pic>
         <p:nvPicPr>
-          <p:cNvPr id="13" name="Picture 12" descr="check_steel.png"/>
+          <p:cNvPr id="16" name="Picture 15" descr="check_white.png"/>
           <p:cNvPicPr>
             <a:picLocks noChangeAspect="1"/>
           </p:cNvPicPr>
@@ -8873,8 +8854,8 @@
         </p:blipFill>
         <p:spPr>
           <a:xfrm>
-            <a:off x="987552" y="3749040"/>
-            <a:ext cx="237744" cy="237744"/>
+            <a:off x="1110447" y="3588471"/>
+            <a:ext cx="266273" cy="266273"/>
           </a:xfrm>
           <a:prstGeom prst="rect">
             <a:avLst/>
@@ -8883,14 +8864,14 @@
       </p:pic>
       <p:sp>
         <p:nvSpPr>
-          <p:cNvPr id="14" name="TextBox 13"/>
+          <p:cNvPr id="17" name="TextBox 16"/>
           <p:cNvSpPr txBox="1"/>
           <p:nvPr/>
         </p:nvSpPr>
         <p:spPr>
           <a:xfrm>
-            <a:off x="1353312" y="3602736"/>
-            <a:ext cx="5029200" cy="530352"/>
+            <a:off x="1627632" y="3328416"/>
+            <a:ext cx="4206240" cy="786384"/>
           </a:xfrm>
           <a:prstGeom prst="rect">
             <a:avLst/>
@@ -8915,7 +8896,7 @@
               </a:spcAft>
             </a:pPr>
             <a:r>
-              <a:rPr sz="1200" b="0">
+              <a:rPr sz="1150" b="0">
                 <a:solidFill>
                   <a:srgbClr val="1A1A1A"/>
                 </a:solidFill>
@@ -8928,18 +8909,18 @@
       </p:sp>
       <p:sp>
         <p:nvSpPr>
-          <p:cNvPr id="15" name="Rounded Rectangle 14"/>
+          <p:cNvPr id="18" name="Rounded Rectangle 17"/>
           <p:cNvSpPr/>
           <p:nvPr/>
         </p:nvSpPr>
         <p:spPr>
           <a:xfrm>
-            <a:off x="841248" y="4206240"/>
-            <a:ext cx="5715000" cy="530352"/>
+            <a:off x="6254496" y="3328416"/>
+            <a:ext cx="5138928" cy="786384"/>
           </a:xfrm>
           <a:prstGeom prst="roundRect">
             <a:avLst>
-              <a:gd name="adj" fmla="val 6000"/>
+              <a:gd name="adj" fmla="val 7000"/>
             </a:avLst>
           </a:prstGeom>
           <a:solidFill>
@@ -8974,9 +8955,55 @@
           </a:p>
         </p:txBody>
       </p:sp>
+      <p:sp>
+        <p:nvSpPr>
+          <p:cNvPr id="19" name="Rounded Rectangle 18"/>
+          <p:cNvSpPr/>
+          <p:nvPr/>
+        </p:nvSpPr>
+        <p:spPr>
+          <a:xfrm>
+            <a:off x="6400800" y="3465576"/>
+            <a:ext cx="512064" cy="512064"/>
+          </a:xfrm>
+          <a:prstGeom prst="roundRect">
+            <a:avLst>
+              <a:gd name="adj" fmla="val 26000"/>
+            </a:avLst>
+          </a:prstGeom>
+          <a:solidFill>
+            <a:srgbClr val="EE0000"/>
+          </a:solidFill>
+          <a:ln>
+            <a:noFill/>
+          </a:ln>
+          <a:effectLst/>
+        </p:spPr>
+        <p:style>
+          <a:lnRef idx="1">
+            <a:schemeClr val="accent1"/>
+          </a:lnRef>
+          <a:fillRef idx="3">
+            <a:schemeClr val="accent1"/>
+          </a:fillRef>
+          <a:effectRef idx="2">
+            <a:schemeClr val="accent1"/>
+          </a:effectRef>
+          <a:fontRef idx="minor">
+            <a:schemeClr val="lt1"/>
+          </a:fontRef>
+        </p:style>
+        <p:txBody>
+          <a:bodyPr rtlCol="0" anchor="ctr"/>
+          <a:lstStyle/>
+          <a:p>
+            <a:pPr algn="ctr"/>
+          </a:p>
+        </p:txBody>
+      </p:sp>
       <p:pic>
         <p:nvPicPr>
-          <p:cNvPr id="16" name="Picture 15" descr="check_steel.png"/>
+          <p:cNvPr id="20" name="Picture 19" descr="check_white.png"/>
           <p:cNvPicPr>
             <a:picLocks noChangeAspect="1"/>
           </p:cNvPicPr>
@@ -8990,8 +9017,8 @@
         </p:blipFill>
         <p:spPr>
           <a:xfrm>
-            <a:off x="987552" y="4352544"/>
-            <a:ext cx="237744" cy="237744"/>
+            <a:off x="6523695" y="3588471"/>
+            <a:ext cx="266273" cy="266273"/>
           </a:xfrm>
           <a:prstGeom prst="rect">
             <a:avLst/>
@@ -9000,14 +9027,14 @@
       </p:pic>
       <p:sp>
         <p:nvSpPr>
-          <p:cNvPr id="17" name="TextBox 16"/>
+          <p:cNvPr id="21" name="TextBox 20"/>
           <p:cNvSpPr txBox="1"/>
           <p:nvPr/>
         </p:nvSpPr>
         <p:spPr>
           <a:xfrm>
-            <a:off x="1353312" y="4206240"/>
-            <a:ext cx="5029200" cy="530352"/>
+            <a:off x="7040880" y="3328416"/>
+            <a:ext cx="4206240" cy="786384"/>
           </a:xfrm>
           <a:prstGeom prst="rect">
             <a:avLst/>
@@ -9032,7 +9059,7 @@
               </a:spcAft>
             </a:pPr>
             <a:r>
-              <a:rPr sz="1200" b="0">
+              <a:rPr sz="1150" b="0">
                 <a:solidFill>
                   <a:srgbClr val="1A1A1A"/>
                 </a:solidFill>
@@ -9045,18 +9072,18 @@
       </p:sp>
       <p:sp>
         <p:nvSpPr>
-          <p:cNvPr id="18" name="Rounded Rectangle 17"/>
+          <p:cNvPr id="22" name="Rounded Rectangle 21"/>
           <p:cNvSpPr/>
           <p:nvPr/>
         </p:nvSpPr>
         <p:spPr>
           <a:xfrm>
-            <a:off x="841248" y="4809744"/>
-            <a:ext cx="5715000" cy="530352"/>
+            <a:off x="841248" y="4261104"/>
+            <a:ext cx="5138928" cy="786384"/>
           </a:xfrm>
           <a:prstGeom prst="roundRect">
             <a:avLst>
-              <a:gd name="adj" fmla="val 6000"/>
+              <a:gd name="adj" fmla="val 7000"/>
             </a:avLst>
           </a:prstGeom>
           <a:solidFill>
@@ -9091,9 +9118,55 @@
           </a:p>
         </p:txBody>
       </p:sp>
+      <p:sp>
+        <p:nvSpPr>
+          <p:cNvPr id="23" name="Rounded Rectangle 22"/>
+          <p:cNvSpPr/>
+          <p:nvPr/>
+        </p:nvSpPr>
+        <p:spPr>
+          <a:xfrm>
+            <a:off x="987552" y="4398264"/>
+            <a:ext cx="512064" cy="512064"/>
+          </a:xfrm>
+          <a:prstGeom prst="roundRect">
+            <a:avLst>
+              <a:gd name="adj" fmla="val 26000"/>
+            </a:avLst>
+          </a:prstGeom>
+          <a:solidFill>
+            <a:srgbClr val="EE0000"/>
+          </a:solidFill>
+          <a:ln>
+            <a:noFill/>
+          </a:ln>
+          <a:effectLst/>
+        </p:spPr>
+        <p:style>
+          <a:lnRef idx="1">
+            <a:schemeClr val="accent1"/>
+          </a:lnRef>
+          <a:fillRef idx="3">
+            <a:schemeClr val="accent1"/>
+          </a:fillRef>
+          <a:effectRef idx="2">
+            <a:schemeClr val="accent1"/>
+          </a:effectRef>
+          <a:fontRef idx="minor">
+            <a:schemeClr val="lt1"/>
+          </a:fontRef>
+        </p:style>
+        <p:txBody>
+          <a:bodyPr rtlCol="0" anchor="ctr"/>
+          <a:lstStyle/>
+          <a:p>
+            <a:pPr algn="ctr"/>
+          </a:p>
+        </p:txBody>
+      </p:sp>
       <p:pic>
         <p:nvPicPr>
-          <p:cNvPr id="19" name="Picture 18" descr="check_steel.png"/>
+          <p:cNvPr id="24" name="Picture 23" descr="check_white.png"/>
           <p:cNvPicPr>
             <a:picLocks noChangeAspect="1"/>
           </p:cNvPicPr>
@@ -9107,8 +9180,8 @@
         </p:blipFill>
         <p:spPr>
           <a:xfrm>
-            <a:off x="987552" y="4956048"/>
-            <a:ext cx="237744" cy="237744"/>
+            <a:off x="1110447" y="4521159"/>
+            <a:ext cx="266273" cy="266273"/>
           </a:xfrm>
           <a:prstGeom prst="rect">
             <a:avLst/>
@@ -9117,14 +9190,14 @@
       </p:pic>
       <p:sp>
         <p:nvSpPr>
-          <p:cNvPr id="20" name="TextBox 19"/>
+          <p:cNvPr id="25" name="TextBox 24"/>
           <p:cNvSpPr txBox="1"/>
           <p:nvPr/>
         </p:nvSpPr>
         <p:spPr>
           <a:xfrm>
-            <a:off x="1353312" y="4809744"/>
-            <a:ext cx="5029200" cy="530352"/>
+            <a:off x="1627632" y="4261104"/>
+            <a:ext cx="4206240" cy="786384"/>
           </a:xfrm>
           <a:prstGeom prst="rect">
             <a:avLst/>
@@ -9149,221 +9222,13 @@
               </a:spcAft>
             </a:pPr>
             <a:r>
-              <a:rPr sz="1200" b="0">
+              <a:rPr sz="1150" b="0">
                 <a:solidFill>
                   <a:srgbClr val="1A1A1A"/>
                 </a:solidFill>
                 <a:latin typeface="Red Hat Text"/>
               </a:rPr>
               <a:t>Ask Lightspeed why Pods restart</a:t>
-            </a:r>
-          </a:p>
-        </p:txBody>
-      </p:sp>
-      <p:sp>
-        <p:nvSpPr>
-          <p:cNvPr id="21" name="Rounded Rectangle 20"/>
-          <p:cNvSpPr/>
-          <p:nvPr/>
-        </p:nvSpPr>
-        <p:spPr>
-          <a:xfrm>
-            <a:off x="6812280" y="2395728"/>
-            <a:ext cx="4538167" cy="2944368"/>
-          </a:xfrm>
-          <a:prstGeom prst="roundRect">
-            <a:avLst>
-              <a:gd name="adj" fmla="val 4000"/>
-            </a:avLst>
-          </a:prstGeom>
-          <a:solidFill>
-            <a:srgbClr val="FFFFFF"/>
-          </a:solidFill>
-          <a:ln w="15240">
-            <a:solidFill>
-              <a:srgbClr val="DDE1E6"/>
-            </a:solidFill>
-          </a:ln>
-          <a:effectLst/>
-        </p:spPr>
-        <p:style>
-          <a:lnRef idx="1">
-            <a:schemeClr val="accent1"/>
-          </a:lnRef>
-          <a:fillRef idx="3">
-            <a:schemeClr val="accent1"/>
-          </a:fillRef>
-          <a:effectRef idx="2">
-            <a:schemeClr val="accent1"/>
-          </a:effectRef>
-          <a:fontRef idx="minor">
-            <a:schemeClr val="lt1"/>
-          </a:fontRef>
-        </p:style>
-        <p:txBody>
-          <a:bodyPr rtlCol="0" anchor="ctr"/>
-          <a:lstStyle/>
-          <a:p>
-            <a:pPr algn="ctr"/>
-          </a:p>
-        </p:txBody>
-      </p:sp>
-      <p:sp>
-        <p:nvSpPr>
-          <p:cNvPr id="22" name="Rounded Rectangle 21"/>
-          <p:cNvSpPr/>
-          <p:nvPr/>
-        </p:nvSpPr>
-        <p:spPr>
-          <a:xfrm>
-            <a:off x="7013448" y="2596896"/>
-            <a:ext cx="1298448" cy="310896"/>
-          </a:xfrm>
-          <a:prstGeom prst="roundRect">
-            <a:avLst>
-              <a:gd name="adj" fmla="val 50000"/>
-            </a:avLst>
-          </a:prstGeom>
-          <a:solidFill>
-            <a:srgbClr val="FCECEC"/>
-          </a:solidFill>
-          <a:ln>
-            <a:noFill/>
-          </a:ln>
-          <a:effectLst/>
-        </p:spPr>
-        <p:style>
-          <a:lnRef idx="1">
-            <a:schemeClr val="accent1"/>
-          </a:lnRef>
-          <a:fillRef idx="3">
-            <a:schemeClr val="accent1"/>
-          </a:fillRef>
-          <a:effectRef idx="2">
-            <a:schemeClr val="accent1"/>
-          </a:effectRef>
-          <a:fontRef idx="minor">
-            <a:schemeClr val="lt1"/>
-          </a:fontRef>
-        </p:style>
-        <p:txBody>
-          <a:bodyPr rtlCol="0" anchor="ctr"/>
-          <a:lstStyle/>
-          <a:p>
-            <a:pPr algn="ctr"/>
-          </a:p>
-        </p:txBody>
-      </p:sp>
-      <p:sp>
-        <p:nvSpPr>
-          <p:cNvPr id="23" name="TextBox 22"/>
-          <p:cNvSpPr txBox="1"/>
-          <p:nvPr/>
-        </p:nvSpPr>
-        <p:spPr>
-          <a:xfrm>
-            <a:off x="7013448" y="2596896"/>
-            <a:ext cx="1298448" cy="310896"/>
-          </a:xfrm>
-          <a:prstGeom prst="rect">
-            <a:avLst/>
-          </a:prstGeom>
-          <a:noFill/>
-        </p:spPr>
-        <p:txBody>
-          <a:bodyPr wrap="none" anchor="ctr" lIns="0" rIns="0" tIns="0" bIns="0">
-            <a:spAutoFit/>
-          </a:bodyPr>
-          <a:lstStyle/>
-          <a:p>
-            <a:pPr algn="ctr">
-              <a:lnSpc>
-                <a:spcPct val="106000"/>
-              </a:lnSpc>
-              <a:spcBef>
-                <a:spcPts val="0"/>
-              </a:spcBef>
-              <a:spcAft>
-                <a:spcPts val="0"/>
-              </a:spcAft>
-            </a:pPr>
-            <a:r>
-              <a:rPr sz="850" b="1">
-                <a:solidFill>
-                  <a:srgbClr val="B80000"/>
-                </a:solidFill>
-                <a:latin typeface="Red Hat Display"/>
-              </a:rPr>
-              <a:t>MEDIA PASS</a:t>
-            </a:r>
-          </a:p>
-        </p:txBody>
-      </p:sp>
-      <p:pic>
-        <p:nvPicPr>
-          <p:cNvPr id="24" name="Picture 23" descr="eye_slate.png"/>
-          <p:cNvPicPr>
-            <a:picLocks noChangeAspect="1"/>
-          </p:cNvPicPr>
-          <p:nvPr/>
-        </p:nvPicPr>
-        <p:blipFill>
-          <a:blip r:embed="rId4"/>
-          <a:stretch>
-            <a:fillRect/>
-          </a:stretch>
-        </p:blipFill>
-        <p:spPr>
-          <a:xfrm>
-            <a:off x="8843619" y="3108960"/>
-            <a:ext cx="475488" cy="475488"/>
-          </a:xfrm>
-          <a:prstGeom prst="rect">
-            <a:avLst/>
-          </a:prstGeom>
-        </p:spPr>
-      </p:pic>
-      <p:sp>
-        <p:nvSpPr>
-          <p:cNvPr id="25" name="TextBox 24"/>
-          <p:cNvSpPr txBox="1"/>
-          <p:nvPr/>
-        </p:nvSpPr>
-        <p:spPr>
-          <a:xfrm>
-            <a:off x="7050024" y="3721608"/>
-            <a:ext cx="4062679" cy="1481328"/>
-          </a:xfrm>
-          <a:prstGeom prst="rect">
-            <a:avLst/>
-          </a:prstGeom>
-          <a:noFill/>
-        </p:spPr>
-        <p:txBody>
-          <a:bodyPr wrap="square" anchor="t" lIns="0" rIns="0" tIns="0" bIns="0">
-            <a:spAutoFit/>
-          </a:bodyPr>
-          <a:lstStyle/>
-          <a:p>
-            <a:pPr algn="l">
-              <a:lnSpc>
-                <a:spcPct val="120000"/>
-              </a:lnSpc>
-              <a:spcBef>
-                <a:spcPts val="0"/>
-              </a:spcBef>
-              <a:spcAft>
-                <a:spcPts val="0"/>
-              </a:spcAft>
-            </a:pPr>
-            <a:r>
-              <a:rPr sz="950" b="0">
-                <a:solidFill>
-                  <a:srgbClr val="8A9099"/>
-                </a:solidFill>
-                <a:latin typeface="Red Hat Text"/>
-              </a:rPr>
-              <a:t>Numbered arc strip: console → deploy → scale/heal → Route → logs → Lightspeed.</a:t>
             </a:r>
           </a:p>
         </p:txBody>
@@ -9671,11 +9536,11 @@
         <p:spPr>
           <a:xfrm>
             <a:off x="841248" y="2395728"/>
-            <a:ext cx="5715000" cy="530352"/>
+            <a:ext cx="5138928" cy="786384"/>
           </a:xfrm>
           <a:prstGeom prst="roundRect">
             <a:avLst>
-              <a:gd name="adj" fmla="val 6000"/>
+              <a:gd name="adj" fmla="val 7000"/>
             </a:avLst>
           </a:prstGeom>
           <a:solidFill>
@@ -9710,9 +9575,55 @@
           </a:p>
         </p:txBody>
       </p:sp>
+      <p:sp>
+        <p:nvSpPr>
+          <p:cNvPr id="7" name="Rounded Rectangle 6"/>
+          <p:cNvSpPr/>
+          <p:nvPr/>
+        </p:nvSpPr>
+        <p:spPr>
+          <a:xfrm>
+            <a:off x="987552" y="2532888"/>
+            <a:ext cx="512064" cy="512064"/>
+          </a:xfrm>
+          <a:prstGeom prst="roundRect">
+            <a:avLst>
+              <a:gd name="adj" fmla="val 26000"/>
+            </a:avLst>
+          </a:prstGeom>
+          <a:solidFill>
+            <a:srgbClr val="EE0000"/>
+          </a:solidFill>
+          <a:ln>
+            <a:noFill/>
+          </a:ln>
+          <a:effectLst/>
+        </p:spPr>
+        <p:style>
+          <a:lnRef idx="1">
+            <a:schemeClr val="accent1"/>
+          </a:lnRef>
+          <a:fillRef idx="3">
+            <a:schemeClr val="accent1"/>
+          </a:fillRef>
+          <a:effectRef idx="2">
+            <a:schemeClr val="accent1"/>
+          </a:effectRef>
+          <a:fontRef idx="minor">
+            <a:schemeClr val="lt1"/>
+          </a:fontRef>
+        </p:style>
+        <p:txBody>
+          <a:bodyPr rtlCol="0" anchor="ctr"/>
+          <a:lstStyle/>
+          <a:p>
+            <a:pPr algn="ctr"/>
+          </a:p>
+        </p:txBody>
+      </p:sp>
       <p:pic>
         <p:nvPicPr>
-          <p:cNvPr id="7" name="Picture 6" descr="check_steel.png"/>
+          <p:cNvPr id="8" name="Picture 7" descr="check_white.png"/>
           <p:cNvPicPr>
             <a:picLocks noChangeAspect="1"/>
           </p:cNvPicPr>
@@ -9726,8 +9637,8 @@
         </p:blipFill>
         <p:spPr>
           <a:xfrm>
-            <a:off x="987552" y="2542032"/>
-            <a:ext cx="237744" cy="237744"/>
+            <a:off x="1110447" y="2655783"/>
+            <a:ext cx="266273" cy="266273"/>
           </a:xfrm>
           <a:prstGeom prst="rect">
             <a:avLst/>
@@ -9736,14 +9647,14 @@
       </p:pic>
       <p:sp>
         <p:nvSpPr>
-          <p:cNvPr id="8" name="TextBox 7"/>
+          <p:cNvPr id="9" name="TextBox 8"/>
           <p:cNvSpPr txBox="1"/>
           <p:nvPr/>
         </p:nvSpPr>
         <p:spPr>
           <a:xfrm>
-            <a:off x="1353312" y="2395728"/>
-            <a:ext cx="5029200" cy="530352"/>
+            <a:off x="1627632" y="2395728"/>
+            <a:ext cx="4206240" cy="786384"/>
           </a:xfrm>
           <a:prstGeom prst="rect">
             <a:avLst/>
@@ -9768,7 +9679,7 @@
               </a:spcAft>
             </a:pPr>
             <a:r>
-              <a:rPr sz="1200" b="0">
+              <a:rPr sz="1150" b="0">
                 <a:solidFill>
                   <a:srgbClr val="1A1A1A"/>
                 </a:solidFill>
@@ -9781,18 +9692,18 @@
       </p:sp>
       <p:sp>
         <p:nvSpPr>
-          <p:cNvPr id="9" name="Rounded Rectangle 8"/>
+          <p:cNvPr id="10" name="Rounded Rectangle 9"/>
           <p:cNvSpPr/>
           <p:nvPr/>
         </p:nvSpPr>
         <p:spPr>
           <a:xfrm>
-            <a:off x="841248" y="2999232"/>
-            <a:ext cx="5715000" cy="530352"/>
+            <a:off x="6254496" y="2395728"/>
+            <a:ext cx="5138928" cy="786384"/>
           </a:xfrm>
           <a:prstGeom prst="roundRect">
             <a:avLst>
-              <a:gd name="adj" fmla="val 6000"/>
+              <a:gd name="adj" fmla="val 7000"/>
             </a:avLst>
           </a:prstGeom>
           <a:solidFill>
@@ -9827,9 +9738,55 @@
           </a:p>
         </p:txBody>
       </p:sp>
+      <p:sp>
+        <p:nvSpPr>
+          <p:cNvPr id="11" name="Rounded Rectangle 10"/>
+          <p:cNvSpPr/>
+          <p:nvPr/>
+        </p:nvSpPr>
+        <p:spPr>
+          <a:xfrm>
+            <a:off x="6400800" y="2532888"/>
+            <a:ext cx="512064" cy="512064"/>
+          </a:xfrm>
+          <a:prstGeom prst="roundRect">
+            <a:avLst>
+              <a:gd name="adj" fmla="val 26000"/>
+            </a:avLst>
+          </a:prstGeom>
+          <a:solidFill>
+            <a:srgbClr val="EE0000"/>
+          </a:solidFill>
+          <a:ln>
+            <a:noFill/>
+          </a:ln>
+          <a:effectLst/>
+        </p:spPr>
+        <p:style>
+          <a:lnRef idx="1">
+            <a:schemeClr val="accent1"/>
+          </a:lnRef>
+          <a:fillRef idx="3">
+            <a:schemeClr val="accent1"/>
+          </a:fillRef>
+          <a:effectRef idx="2">
+            <a:schemeClr val="accent1"/>
+          </a:effectRef>
+          <a:fontRef idx="minor">
+            <a:schemeClr val="lt1"/>
+          </a:fontRef>
+        </p:style>
+        <p:txBody>
+          <a:bodyPr rtlCol="0" anchor="ctr"/>
+          <a:lstStyle/>
+          <a:p>
+            <a:pPr algn="ctr"/>
+          </a:p>
+        </p:txBody>
+      </p:sp>
       <p:pic>
         <p:nvPicPr>
-          <p:cNvPr id="10" name="Picture 9" descr="check_steel.png"/>
+          <p:cNvPr id="12" name="Picture 11" descr="check_white.png"/>
           <p:cNvPicPr>
             <a:picLocks noChangeAspect="1"/>
           </p:cNvPicPr>
@@ -9843,8 +9800,8 @@
         </p:blipFill>
         <p:spPr>
           <a:xfrm>
-            <a:off x="987552" y="3145536"/>
-            <a:ext cx="237744" cy="237744"/>
+            <a:off x="6523695" y="2655783"/>
+            <a:ext cx="266273" cy="266273"/>
           </a:xfrm>
           <a:prstGeom prst="rect">
             <a:avLst/>
@@ -9853,14 +9810,14 @@
       </p:pic>
       <p:sp>
         <p:nvSpPr>
-          <p:cNvPr id="11" name="TextBox 10"/>
+          <p:cNvPr id="13" name="TextBox 12"/>
           <p:cNvSpPr txBox="1"/>
           <p:nvPr/>
         </p:nvSpPr>
         <p:spPr>
           <a:xfrm>
-            <a:off x="1353312" y="2999232"/>
-            <a:ext cx="5029200" cy="530352"/>
+            <a:off x="7040880" y="2395728"/>
+            <a:ext cx="4206240" cy="786384"/>
           </a:xfrm>
           <a:prstGeom prst="rect">
             <a:avLst/>
@@ -9885,7 +9842,7 @@
               </a:spcAft>
             </a:pPr>
             <a:r>
-              <a:rPr sz="1200" b="0">
+              <a:rPr sz="1150" b="0">
                 <a:solidFill>
                   <a:srgbClr val="1A1A1A"/>
                 </a:solidFill>
@@ -9898,18 +9855,18 @@
       </p:sp>
       <p:sp>
         <p:nvSpPr>
-          <p:cNvPr id="12" name="Rounded Rectangle 11"/>
+          <p:cNvPr id="14" name="Rounded Rectangle 13"/>
           <p:cNvSpPr/>
           <p:nvPr/>
         </p:nvSpPr>
         <p:spPr>
           <a:xfrm>
-            <a:off x="841248" y="3602736"/>
-            <a:ext cx="5715000" cy="530352"/>
+            <a:off x="841248" y="3328416"/>
+            <a:ext cx="5138928" cy="786384"/>
           </a:xfrm>
           <a:prstGeom prst="roundRect">
             <a:avLst>
-              <a:gd name="adj" fmla="val 6000"/>
+              <a:gd name="adj" fmla="val 7000"/>
             </a:avLst>
           </a:prstGeom>
           <a:solidFill>
@@ -9944,9 +9901,55 @@
           </a:p>
         </p:txBody>
       </p:sp>
+      <p:sp>
+        <p:nvSpPr>
+          <p:cNvPr id="15" name="Rounded Rectangle 14"/>
+          <p:cNvSpPr/>
+          <p:nvPr/>
+        </p:nvSpPr>
+        <p:spPr>
+          <a:xfrm>
+            <a:off x="987552" y="3465576"/>
+            <a:ext cx="512064" cy="512064"/>
+          </a:xfrm>
+          <a:prstGeom prst="roundRect">
+            <a:avLst>
+              <a:gd name="adj" fmla="val 26000"/>
+            </a:avLst>
+          </a:prstGeom>
+          <a:solidFill>
+            <a:srgbClr val="EE0000"/>
+          </a:solidFill>
+          <a:ln>
+            <a:noFill/>
+          </a:ln>
+          <a:effectLst/>
+        </p:spPr>
+        <p:style>
+          <a:lnRef idx="1">
+            <a:schemeClr val="accent1"/>
+          </a:lnRef>
+          <a:fillRef idx="3">
+            <a:schemeClr val="accent1"/>
+          </a:fillRef>
+          <a:effectRef idx="2">
+            <a:schemeClr val="accent1"/>
+          </a:effectRef>
+          <a:fontRef idx="minor">
+            <a:schemeClr val="lt1"/>
+          </a:fontRef>
+        </p:style>
+        <p:txBody>
+          <a:bodyPr rtlCol="0" anchor="ctr"/>
+          <a:lstStyle/>
+          <a:p>
+            <a:pPr algn="ctr"/>
+          </a:p>
+        </p:txBody>
+      </p:sp>
       <p:pic>
         <p:nvPicPr>
-          <p:cNvPr id="13" name="Picture 12" descr="check_steel.png"/>
+          <p:cNvPr id="16" name="Picture 15" descr="check_white.png"/>
           <p:cNvPicPr>
             <a:picLocks noChangeAspect="1"/>
           </p:cNvPicPr>
@@ -9960,8 +9963,8 @@
         </p:blipFill>
         <p:spPr>
           <a:xfrm>
-            <a:off x="987552" y="3749040"/>
-            <a:ext cx="237744" cy="237744"/>
+            <a:off x="1110447" y="3588471"/>
+            <a:ext cx="266273" cy="266273"/>
           </a:xfrm>
           <a:prstGeom prst="rect">
             <a:avLst/>
@@ -9970,14 +9973,14 @@
       </p:pic>
       <p:sp>
         <p:nvSpPr>
-          <p:cNvPr id="14" name="TextBox 13"/>
+          <p:cNvPr id="17" name="TextBox 16"/>
           <p:cNvSpPr txBox="1"/>
           <p:nvPr/>
         </p:nvSpPr>
         <p:spPr>
           <a:xfrm>
-            <a:off x="1353312" y="3602736"/>
-            <a:ext cx="5029200" cy="530352"/>
+            <a:off x="1627632" y="3328416"/>
+            <a:ext cx="4206240" cy="786384"/>
           </a:xfrm>
           <a:prstGeom prst="rect">
             <a:avLst/>
@@ -10002,7 +10005,7 @@
               </a:spcAft>
             </a:pPr>
             <a:r>
-              <a:rPr sz="1200" b="0">
+              <a:rPr sz="1150" b="0">
                 <a:solidFill>
                   <a:srgbClr val="1A1A1A"/>
                 </a:solidFill>
@@ -10015,18 +10018,18 @@
       </p:sp>
       <p:sp>
         <p:nvSpPr>
-          <p:cNvPr id="15" name="Rounded Rectangle 14"/>
+          <p:cNvPr id="18" name="Rounded Rectangle 17"/>
           <p:cNvSpPr/>
           <p:nvPr/>
         </p:nvSpPr>
         <p:spPr>
           <a:xfrm>
-            <a:off x="841248" y="4206240"/>
-            <a:ext cx="5715000" cy="530352"/>
+            <a:off x="6254496" y="3328416"/>
+            <a:ext cx="5138928" cy="786384"/>
           </a:xfrm>
           <a:prstGeom prst="roundRect">
             <a:avLst>
-              <a:gd name="adj" fmla="val 6000"/>
+              <a:gd name="adj" fmla="val 7000"/>
             </a:avLst>
           </a:prstGeom>
           <a:solidFill>
@@ -10061,9 +10064,55 @@
           </a:p>
         </p:txBody>
       </p:sp>
+      <p:sp>
+        <p:nvSpPr>
+          <p:cNvPr id="19" name="Rounded Rectangle 18"/>
+          <p:cNvSpPr/>
+          <p:nvPr/>
+        </p:nvSpPr>
+        <p:spPr>
+          <a:xfrm>
+            <a:off x="6400800" y="3465576"/>
+            <a:ext cx="512064" cy="512064"/>
+          </a:xfrm>
+          <a:prstGeom prst="roundRect">
+            <a:avLst>
+              <a:gd name="adj" fmla="val 26000"/>
+            </a:avLst>
+          </a:prstGeom>
+          <a:solidFill>
+            <a:srgbClr val="EE0000"/>
+          </a:solidFill>
+          <a:ln>
+            <a:noFill/>
+          </a:ln>
+          <a:effectLst/>
+        </p:spPr>
+        <p:style>
+          <a:lnRef idx="1">
+            <a:schemeClr val="accent1"/>
+          </a:lnRef>
+          <a:fillRef idx="3">
+            <a:schemeClr val="accent1"/>
+          </a:fillRef>
+          <a:effectRef idx="2">
+            <a:schemeClr val="accent1"/>
+          </a:effectRef>
+          <a:fontRef idx="minor">
+            <a:schemeClr val="lt1"/>
+          </a:fontRef>
+        </p:style>
+        <p:txBody>
+          <a:bodyPr rtlCol="0" anchor="ctr"/>
+          <a:lstStyle/>
+          <a:p>
+            <a:pPr algn="ctr"/>
+          </a:p>
+        </p:txBody>
+      </p:sp>
       <p:pic>
         <p:nvPicPr>
-          <p:cNvPr id="16" name="Picture 15" descr="check_steel.png"/>
+          <p:cNvPr id="20" name="Picture 19" descr="check_white.png"/>
           <p:cNvPicPr>
             <a:picLocks noChangeAspect="1"/>
           </p:cNvPicPr>
@@ -10077,8 +10126,8 @@
         </p:blipFill>
         <p:spPr>
           <a:xfrm>
-            <a:off x="987552" y="4352544"/>
-            <a:ext cx="237744" cy="237744"/>
+            <a:off x="6523695" y="3588471"/>
+            <a:ext cx="266273" cy="266273"/>
           </a:xfrm>
           <a:prstGeom prst="rect">
             <a:avLst/>
@@ -10087,14 +10136,14 @@
       </p:pic>
       <p:sp>
         <p:nvSpPr>
-          <p:cNvPr id="17" name="TextBox 16"/>
+          <p:cNvPr id="21" name="TextBox 20"/>
           <p:cNvSpPr txBox="1"/>
           <p:nvPr/>
         </p:nvSpPr>
         <p:spPr>
           <a:xfrm>
-            <a:off x="1353312" y="4206240"/>
-            <a:ext cx="5029200" cy="530352"/>
+            <a:off x="7040880" y="3328416"/>
+            <a:ext cx="4206240" cy="786384"/>
           </a:xfrm>
           <a:prstGeom prst="rect">
             <a:avLst/>
@@ -10119,7 +10168,7 @@
               </a:spcAft>
             </a:pPr>
             <a:r>
-              <a:rPr sz="1200" b="0">
+              <a:rPr sz="1150" b="0">
                 <a:solidFill>
                   <a:srgbClr val="1A1A1A"/>
                 </a:solidFill>
@@ -10132,18 +10181,18 @@
       </p:sp>
       <p:sp>
         <p:nvSpPr>
-          <p:cNvPr id="18" name="Rounded Rectangle 17"/>
+          <p:cNvPr id="22" name="Rounded Rectangle 21"/>
           <p:cNvSpPr/>
           <p:nvPr/>
         </p:nvSpPr>
         <p:spPr>
           <a:xfrm>
-            <a:off x="841248" y="4809744"/>
-            <a:ext cx="5715000" cy="530352"/>
+            <a:off x="841248" y="4261104"/>
+            <a:ext cx="5138928" cy="786384"/>
           </a:xfrm>
           <a:prstGeom prst="roundRect">
             <a:avLst>
-              <a:gd name="adj" fmla="val 6000"/>
+              <a:gd name="adj" fmla="val 7000"/>
             </a:avLst>
           </a:prstGeom>
           <a:solidFill>
@@ -10178,9 +10227,55 @@
           </a:p>
         </p:txBody>
       </p:sp>
+      <p:sp>
+        <p:nvSpPr>
+          <p:cNvPr id="23" name="Rounded Rectangle 22"/>
+          <p:cNvSpPr/>
+          <p:nvPr/>
+        </p:nvSpPr>
+        <p:spPr>
+          <a:xfrm>
+            <a:off x="987552" y="4398264"/>
+            <a:ext cx="512064" cy="512064"/>
+          </a:xfrm>
+          <a:prstGeom prst="roundRect">
+            <a:avLst>
+              <a:gd name="adj" fmla="val 26000"/>
+            </a:avLst>
+          </a:prstGeom>
+          <a:solidFill>
+            <a:srgbClr val="EE0000"/>
+          </a:solidFill>
+          <a:ln>
+            <a:noFill/>
+          </a:ln>
+          <a:effectLst/>
+        </p:spPr>
+        <p:style>
+          <a:lnRef idx="1">
+            <a:schemeClr val="accent1"/>
+          </a:lnRef>
+          <a:fillRef idx="3">
+            <a:schemeClr val="accent1"/>
+          </a:fillRef>
+          <a:effectRef idx="2">
+            <a:schemeClr val="accent1"/>
+          </a:effectRef>
+          <a:fontRef idx="minor">
+            <a:schemeClr val="lt1"/>
+          </a:fontRef>
+        </p:style>
+        <p:txBody>
+          <a:bodyPr rtlCol="0" anchor="ctr"/>
+          <a:lstStyle/>
+          <a:p>
+            <a:pPr algn="ctr"/>
+          </a:p>
+        </p:txBody>
+      </p:sp>
       <p:pic>
         <p:nvPicPr>
-          <p:cNvPr id="19" name="Picture 18" descr="check_steel.png"/>
+          <p:cNvPr id="24" name="Picture 23" descr="check_white.png"/>
           <p:cNvPicPr>
             <a:picLocks noChangeAspect="1"/>
           </p:cNvPicPr>
@@ -10194,8 +10289,8 @@
         </p:blipFill>
         <p:spPr>
           <a:xfrm>
-            <a:off x="987552" y="4956048"/>
-            <a:ext cx="237744" cy="237744"/>
+            <a:off x="1110447" y="4521159"/>
+            <a:ext cx="266273" cy="266273"/>
           </a:xfrm>
           <a:prstGeom prst="rect">
             <a:avLst/>
@@ -10204,14 +10299,14 @@
       </p:pic>
       <p:sp>
         <p:nvSpPr>
-          <p:cNvPr id="20" name="TextBox 19"/>
+          <p:cNvPr id="25" name="TextBox 24"/>
           <p:cNvSpPr txBox="1"/>
           <p:nvPr/>
         </p:nvSpPr>
         <p:spPr>
           <a:xfrm>
-            <a:off x="1353312" y="4809744"/>
-            <a:ext cx="5029200" cy="530352"/>
+            <a:off x="1627632" y="4261104"/>
+            <a:ext cx="4206240" cy="786384"/>
           </a:xfrm>
           <a:prstGeom prst="rect">
             <a:avLst/>
@@ -10236,7 +10331,7 @@
               </a:spcAft>
             </a:pPr>
             <a:r>
-              <a:rPr sz="1200" b="0">
+              <a:rPr sz="1150" b="0">
                 <a:solidFill>
                   <a:srgbClr val="1A1A1A"/>
                 </a:solidFill>
@@ -10247,16 +10342,310 @@
           </a:p>
         </p:txBody>
       </p:sp>
-      <p:sp>
-        <p:nvSpPr>
-          <p:cNvPr id="21" name="Rounded Rectangle 20"/>
+      <p:cxnSp>
+        <p:nvCxnSpPr>
+          <p:cNvPr id="26" name="Connector 25"/>
+          <p:cNvCxnSpPr/>
+          <p:nvPr/>
+        </p:nvCxnSpPr>
+        <p:spPr>
+          <a:xfrm>
+            <a:off x="841248" y="6437376"/>
+            <a:ext cx="10509199" cy="0"/>
+          </a:xfrm>
+          <a:prstGeom prst="bentConnector3">
+            <a:avLst/>
+          </a:prstGeom>
+          <a:ln w="12700">
+            <a:solidFill>
+              <a:srgbClr val="DDE1E6"/>
+            </a:solidFill>
+          </a:ln>
+          <a:effectLst/>
+        </p:spPr>
+        <p:style>
+          <a:lnRef idx="2">
+            <a:schemeClr val="accent1"/>
+          </a:lnRef>
+          <a:fillRef idx="0">
+            <a:schemeClr val="accent1"/>
+          </a:fillRef>
+          <a:effectRef idx="1">
+            <a:schemeClr val="accent1"/>
+          </a:effectRef>
+          <a:fontRef idx="minor">
+            <a:schemeClr val="tx1"/>
+          </a:fontRef>
+        </p:style>
+      </p:cxnSp>
+      <p:sp>
+        <p:nvSpPr>
+          <p:cNvPr id="27" name="TextBox 26"/>
+          <p:cNvSpPr txBox="1"/>
+          <p:nvPr/>
+        </p:nvSpPr>
+        <p:spPr>
+          <a:xfrm>
+            <a:off x="841248" y="6473952"/>
+            <a:ext cx="7315200" cy="274320"/>
+          </a:xfrm>
+          <a:prstGeom prst="rect">
+            <a:avLst/>
+          </a:prstGeom>
+          <a:noFill/>
+        </p:spPr>
+        <p:txBody>
+          <a:bodyPr wrap="square" anchor="t" lIns="0" rIns="0" tIns="0" bIns="0">
+            <a:spAutoFit/>
+          </a:bodyPr>
+          <a:lstStyle/>
+          <a:p>
+            <a:pPr algn="l">
+              <a:lnSpc>
+                <a:spcPct val="106000"/>
+              </a:lnSpc>
+              <a:spcBef>
+                <a:spcPts val="0"/>
+              </a:spcBef>
+              <a:spcAft>
+                <a:spcPts val="0"/>
+              </a:spcAft>
+            </a:pPr>
+            <a:r>
+              <a:rPr sz="950" b="0">
+                <a:solidFill>
+                  <a:srgbClr val="8A9099"/>
+                </a:solidFill>
+                <a:latin typeface="Red Hat Text"/>
+              </a:rPr>
+              <a:t>CONFIDENTIAL</a:t>
+            </a:r>
+          </a:p>
+        </p:txBody>
+      </p:sp>
+      <p:sp>
+        <p:nvSpPr>
+          <p:cNvPr id="28" name="TextBox 27"/>
+          <p:cNvSpPr txBox="1"/>
+          <p:nvPr/>
+        </p:nvSpPr>
+        <p:spPr>
+          <a:xfrm>
+            <a:off x="10801807" y="6473952"/>
+            <a:ext cx="548640" cy="274320"/>
+          </a:xfrm>
+          <a:prstGeom prst="rect">
+            <a:avLst/>
+          </a:prstGeom>
+          <a:noFill/>
+        </p:spPr>
+        <p:txBody>
+          <a:bodyPr wrap="square" anchor="t" lIns="0" rIns="0" tIns="0" bIns="0">
+            <a:spAutoFit/>
+          </a:bodyPr>
+          <a:lstStyle/>
+          <a:p>
+            <a:pPr algn="r">
+              <a:lnSpc>
+                <a:spcPct val="106000"/>
+              </a:lnSpc>
+              <a:spcBef>
+                <a:spcPts val="0"/>
+              </a:spcBef>
+              <a:spcAft>
+                <a:spcPts val="0"/>
+              </a:spcAft>
+            </a:pPr>
+            <a:r>
+              <a:rPr sz="950" b="0">
+                <a:solidFill>
+                  <a:srgbClr val="8A9099"/>
+                </a:solidFill>
+                <a:latin typeface="Red Hat Text"/>
+              </a:rPr>
+              <a:t>6</a:t>
+            </a:r>
+          </a:p>
+        </p:txBody>
+      </p:sp>
+    </p:spTree>
+  </p:cSld>
+  <p:clrMapOvr>
+    <a:masterClrMapping/>
+  </p:clrMapOvr>
+</p:sld>
+</file>
+
+<file path=ppt/slides/slide8.xml><?xml version="1.0" encoding="utf-8"?>
+<p:sld xmlns:a="http://schemas.openxmlformats.org/drawingml/2006/main" xmlns:p="http://schemas.openxmlformats.org/presentationml/2006/main" xmlns:r="http://schemas.openxmlformats.org/officeDocument/2006/relationships">
+  <p:cSld>
+    <p:spTree>
+      <p:nvGrpSpPr>
+        <p:cNvPr id="1" name=""/>
+        <p:cNvGrpSpPr/>
+        <p:nvPr/>
+      </p:nvGrpSpPr>
+      <p:grpSpPr/>
+      <p:pic>
+        <p:nvPicPr>
+          <p:cNvPr id="2" name="Picture 1" descr="redhat_logo.jpg"/>
+          <p:cNvPicPr>
+            <a:picLocks noChangeAspect="1"/>
+          </p:cNvPicPr>
+          <p:nvPr/>
+        </p:nvPicPr>
+        <p:blipFill>
+          <a:blip r:embed="rId2"/>
+          <a:stretch>
+            <a:fillRect/>
+          </a:stretch>
+        </p:blipFill>
+        <p:spPr>
+          <a:xfrm>
+            <a:off x="10326319" y="475488"/>
+            <a:ext cx="1024128" cy="242248"/>
+          </a:xfrm>
+          <a:prstGeom prst="rect">
+            <a:avLst/>
+          </a:prstGeom>
+        </p:spPr>
+      </p:pic>
+      <p:sp>
+        <p:nvSpPr>
+          <p:cNvPr id="3" name="TextBox 2"/>
+          <p:cNvSpPr txBox="1"/>
+          <p:nvPr/>
+        </p:nvSpPr>
+        <p:spPr>
+          <a:xfrm>
+            <a:off x="841248" y="548640"/>
+            <a:ext cx="8595360" cy="274320"/>
+          </a:xfrm>
+          <a:prstGeom prst="rect">
+            <a:avLst/>
+          </a:prstGeom>
+          <a:noFill/>
+        </p:spPr>
+        <p:txBody>
+          <a:bodyPr wrap="square" anchor="t" lIns="0" rIns="0" tIns="0" bIns="0">
+            <a:spAutoFit/>
+          </a:bodyPr>
+          <a:lstStyle/>
+          <a:p>
+            <a:pPr algn="l">
+              <a:lnSpc>
+                <a:spcPct val="106000"/>
+              </a:lnSpc>
+              <a:spcBef>
+                <a:spcPts val="0"/>
+              </a:spcBef>
+              <a:spcAft>
+                <a:spcPts val="0"/>
+              </a:spcAft>
+            </a:pPr>
+            <a:r>
+              <a:rPr sz="1250" b="1" spc="220">
+                <a:solidFill>
+                  <a:srgbClr val="EE0000"/>
+                </a:solidFill>
+                <a:latin typeface="Red Hat Display"/>
+              </a:rPr>
+              <a:t>M01 · PLATFORM ORIENTATION &amp; FIRST APP</a:t>
+            </a:r>
+          </a:p>
+        </p:txBody>
+      </p:sp>
+      <p:sp>
+        <p:nvSpPr>
+          <p:cNvPr id="4" name="TextBox 3"/>
+          <p:cNvSpPr txBox="1"/>
+          <p:nvPr/>
+        </p:nvSpPr>
+        <p:spPr>
+          <a:xfrm>
+            <a:off x="841248" y="877824"/>
+            <a:ext cx="10515600" cy="548640"/>
+          </a:xfrm>
+          <a:prstGeom prst="rect">
+            <a:avLst/>
+          </a:prstGeom>
+          <a:noFill/>
+        </p:spPr>
+        <p:txBody>
+          <a:bodyPr wrap="none" anchor="t" lIns="0" rIns="0" tIns="0" bIns="0">
+            <a:spAutoFit/>
+          </a:bodyPr>
+          <a:lstStyle/>
+          <a:p>
+            <a:pPr algn="l">
+              <a:lnSpc>
+                <a:spcPct val="100000"/>
+              </a:lnSpc>
+              <a:spcBef>
+                <a:spcPts val="0"/>
+              </a:spcBef>
+              <a:spcAft>
+                <a:spcPts val="0"/>
+              </a:spcAft>
+            </a:pPr>
+            <a:r>
+              <a:rPr sz="2500" b="1">
+                <a:solidFill>
+                  <a:srgbClr val="1A1A1A"/>
+                </a:solidFill>
+                <a:latin typeface="Red Hat Display"/>
+              </a:rPr>
+              <a:t>What you built</a:t>
+            </a:r>
+          </a:p>
+        </p:txBody>
+      </p:sp>
+      <p:cxnSp>
+        <p:nvCxnSpPr>
+          <p:cNvPr id="5" name="Connector 4"/>
+          <p:cNvCxnSpPr/>
+          <p:nvPr/>
+        </p:nvCxnSpPr>
+        <p:spPr>
+          <a:xfrm>
+            <a:off x="841248" y="1554480"/>
+            <a:ext cx="1371600" cy="0"/>
+          </a:xfrm>
+          <a:prstGeom prst="bentConnector3">
+            <a:avLst/>
+          </a:prstGeom>
+          <a:ln w="31750">
+            <a:solidFill>
+              <a:srgbClr val="EE0000"/>
+            </a:solidFill>
+          </a:ln>
+          <a:effectLst/>
+        </p:spPr>
+        <p:style>
+          <a:lnRef idx="2">
+            <a:schemeClr val="accent1"/>
+          </a:lnRef>
+          <a:fillRef idx="0">
+            <a:schemeClr val="accent1"/>
+          </a:fillRef>
+          <a:effectRef idx="1">
+            <a:schemeClr val="accent1"/>
+          </a:effectRef>
+          <a:fontRef idx="minor">
+            <a:schemeClr val="tx1"/>
+          </a:fontRef>
+        </p:style>
+      </p:cxnSp>
+      <p:sp>
+        <p:nvSpPr>
+          <p:cNvPr id="6" name="Rounded Rectangle 5"/>
           <p:cNvSpPr/>
           <p:nvPr/>
         </p:nvSpPr>
         <p:spPr>
           <a:xfrm>
-            <a:off x="6812280" y="2395728"/>
-            <a:ext cx="4538167" cy="2944368"/>
+            <a:off x="841248" y="2331720"/>
+            <a:ext cx="10509199" cy="3794760"/>
           </a:xfrm>
           <a:prstGeom prst="roundRect">
             <a:avLst>
@@ -10295,169 +10684,33 @@
           </a:p>
         </p:txBody>
       </p:sp>
-      <p:sp>
-        <p:nvSpPr>
-          <p:cNvPr id="22" name="Rounded Rectangle 21"/>
-          <p:cNvSpPr/>
-          <p:nvPr/>
-        </p:nvSpPr>
-        <p:spPr>
-          <a:xfrm>
-            <a:off x="7013448" y="2596896"/>
-            <a:ext cx="1298448" cy="310896"/>
-          </a:xfrm>
-          <a:prstGeom prst="roundRect">
-            <a:avLst>
-              <a:gd name="adj" fmla="val 50000"/>
-            </a:avLst>
-          </a:prstGeom>
-          <a:solidFill>
-            <a:srgbClr val="FCECEC"/>
-          </a:solidFill>
-          <a:ln>
-            <a:noFill/>
-          </a:ln>
-          <a:effectLst/>
-        </p:spPr>
-        <p:style>
-          <a:lnRef idx="1">
-            <a:schemeClr val="accent1"/>
-          </a:lnRef>
-          <a:fillRef idx="3">
-            <a:schemeClr val="accent1"/>
-          </a:fillRef>
-          <a:effectRef idx="2">
-            <a:schemeClr val="accent1"/>
-          </a:effectRef>
-          <a:fontRef idx="minor">
-            <a:schemeClr val="lt1"/>
-          </a:fontRef>
-        </p:style>
-        <p:txBody>
-          <a:bodyPr rtlCol="0" anchor="ctr"/>
-          <a:lstStyle/>
-          <a:p>
-            <a:pPr algn="ctr"/>
-          </a:p>
-        </p:txBody>
-      </p:sp>
-      <p:sp>
-        <p:nvSpPr>
-          <p:cNvPr id="23" name="TextBox 22"/>
-          <p:cNvSpPr txBox="1"/>
-          <p:nvPr/>
-        </p:nvSpPr>
-        <p:spPr>
-          <a:xfrm>
-            <a:off x="7013448" y="2596896"/>
-            <a:ext cx="1298448" cy="310896"/>
-          </a:xfrm>
-          <a:prstGeom prst="rect">
-            <a:avLst/>
-          </a:prstGeom>
-          <a:noFill/>
-        </p:spPr>
-        <p:txBody>
-          <a:bodyPr wrap="none" anchor="ctr" lIns="0" rIns="0" tIns="0" bIns="0">
-            <a:spAutoFit/>
-          </a:bodyPr>
-          <a:lstStyle/>
-          <a:p>
-            <a:pPr algn="ctr">
-              <a:lnSpc>
-                <a:spcPct val="106000"/>
-              </a:lnSpc>
-              <a:spcBef>
-                <a:spcPts val="0"/>
-              </a:spcBef>
-              <a:spcAft>
-                <a:spcPts val="0"/>
-              </a:spcAft>
-            </a:pPr>
-            <a:r>
-              <a:rPr sz="850" b="1">
-                <a:solidFill>
-                  <a:srgbClr val="B80000"/>
-                </a:solidFill>
-                <a:latin typeface="Red Hat Display"/>
-              </a:rPr>
-              <a:t>MEDIA PASS</a:t>
-            </a:r>
-          </a:p>
-        </p:txBody>
-      </p:sp>
       <p:pic>
         <p:nvPicPr>
-          <p:cNvPr id="24" name="Picture 23" descr="eye_slate.png"/>
+          <p:cNvPr id="7" name="Picture 6" descr="03-what-you-built.png"/>
           <p:cNvPicPr>
             <a:picLocks noChangeAspect="1"/>
           </p:cNvPicPr>
           <p:nvPr/>
         </p:nvPicPr>
         <p:blipFill>
-          <a:blip r:embed="rId4"/>
+          <a:blip r:embed="rId3"/>
           <a:stretch>
             <a:fillRect/>
           </a:stretch>
         </p:blipFill>
         <p:spPr>
           <a:xfrm>
-            <a:off x="8843619" y="3108960"/>
-            <a:ext cx="475488" cy="475488"/>
+            <a:off x="1042416" y="3467926"/>
+            <a:ext cx="10106863" cy="1522346"/>
           </a:xfrm>
           <a:prstGeom prst="rect">
             <a:avLst/>
           </a:prstGeom>
         </p:spPr>
       </p:pic>
-      <p:sp>
-        <p:nvSpPr>
-          <p:cNvPr id="25" name="TextBox 24"/>
-          <p:cNvSpPr txBox="1"/>
-          <p:nvPr/>
-        </p:nvSpPr>
-        <p:spPr>
-          <a:xfrm>
-            <a:off x="7050024" y="3721608"/>
-            <a:ext cx="4062679" cy="1481328"/>
-          </a:xfrm>
-          <a:prstGeom prst="rect">
-            <a:avLst/>
-          </a:prstGeom>
-          <a:noFill/>
-        </p:spPr>
-        <p:txBody>
-          <a:bodyPr wrap="square" anchor="t" lIns="0" rIns="0" tIns="0" bIns="0">
-            <a:spAutoFit/>
-          </a:bodyPr>
-          <a:lstStyle/>
-          <a:p>
-            <a:pPr algn="l">
-              <a:lnSpc>
-                <a:spcPct val="120000"/>
-              </a:lnSpc>
-              <a:spcBef>
-                <a:spcPts val="0"/>
-              </a:spcBef>
-              <a:spcAft>
-                <a:spcPts val="0"/>
-              </a:spcAft>
-            </a:pPr>
-            <a:r>
-              <a:rPr sz="950" b="0">
-                <a:solidFill>
-                  <a:srgbClr val="8A9099"/>
-                </a:solidFill>
-                <a:latin typeface="Red Hat Text"/>
-              </a:rPr>
-              <a:t>Two-column "cattle by default / pet on purpose" decision card.</a:t>
-            </a:r>
-          </a:p>
-        </p:txBody>
-      </p:sp>
       <p:cxnSp>
         <p:nvCxnSpPr>
-          <p:cNvPr id="26" name="Connector 25"/>
+          <p:cNvPr id="8" name="Connector 7"/>
           <p:cNvCxnSpPr/>
           <p:nvPr/>
         </p:nvCxnSpPr>
@@ -10493,7 +10746,7 @@
       </p:cxnSp>
       <p:sp>
         <p:nvSpPr>
-          <p:cNvPr id="27" name="TextBox 26"/>
+          <p:cNvPr id="9" name="TextBox 8"/>
           <p:cNvSpPr txBox="1"/>
           <p:nvPr/>
         </p:nvSpPr>
@@ -10538,7 +10791,7 @@
       </p:sp>
       <p:sp>
         <p:nvSpPr>
-          <p:cNvPr id="28" name="TextBox 27"/>
+          <p:cNvPr id="10" name="TextBox 9"/>
           <p:cNvSpPr txBox="1"/>
           <p:nvPr/>
         </p:nvSpPr>
@@ -10576,7 +10829,7 @@
                 </a:solidFill>
                 <a:latin typeface="Red Hat Text"/>
               </a:rPr>
-              <a:t>6</a:t>
+              <a:t>7</a:t>
             </a:r>
           </a:p>
         </p:txBody>

</xml_diff>